<commit_message>
fix: enforce full Point deck semantics
</commit_message>
<xml_diff>
--- a/examples/intel-rats/to-deck-prose-v2/final/summary/intel-tdx-attestation-prose-summary.pptx
+++ b/examples/intel-rats/to-deck-prose-v2/final/summary/intel-tdx-attestation-prose-summary.pptx
@@ -1040,7 +1040,7 @@
                 <a:ea typeface="Apple SD Gothic Neo" pitchFamily="34" charset="-122"/>
                 <a:cs typeface="Apple SD Gothic Neo" pitchFamily="34" charset="-120"/>
               </a:rPr>
-              <a:t>원격 증명은 Evidence를 평가하는 사람과 비밀 공개를 결정하는 사람을 분리하는 release control이다.</a:t>
+              <a:t>TDQE가 서명한 Evidence를 Verifier가 평가하고, RP/KMS가 별도 공개 정책으로 마지막 행동을 결정한다.</a:t>
             </a:r>
             <a:endParaRPr lang="en-US" sz="1430" dirty="0"/>
           </a:p>
@@ -1095,8 +1095,8 @@
         </p:nvSpPr>
         <p:spPr>
           <a:xfrm>
-            <a:off x="566928" y="1600200"/>
-            <a:ext cx="2834640" cy="2697480"/>
+            <a:off x="566928" y="1508760"/>
+            <a:ext cx="2834640" cy="2514600"/>
           </a:xfrm>
           <a:prstGeom prst="roundRect">
             <a:avLst/>
@@ -1120,7 +1120,7 @@
         </p:nvSpPr>
         <p:spPr>
           <a:xfrm>
-            <a:off x="731520" y="1764792"/>
+            <a:off x="731520" y="1673352"/>
             <a:ext cx="1152144" cy="256032"/>
           </a:xfrm>
           <a:prstGeom prst="roundRect">
@@ -1145,7 +1145,7 @@
         </p:nvSpPr>
         <p:spPr>
           <a:xfrm>
-            <a:off x="731520" y="1833372"/>
+            <a:off x="731520" y="1741932"/>
             <a:ext cx="1152144" cy="91440"/>
           </a:xfrm>
           <a:prstGeom prst="rect">
@@ -1186,7 +1186,7 @@
         </p:nvSpPr>
         <p:spPr>
           <a:xfrm>
-            <a:off x="749808" y="2176272"/>
+            <a:off x="749808" y="2084832"/>
             <a:ext cx="2468880" cy="256032"/>
           </a:xfrm>
           <a:prstGeom prst="rect">
@@ -1213,7 +1213,7 @@
                 <a:ea typeface="Apple SD Gothic Neo" pitchFamily="34" charset="-122"/>
                 <a:cs typeface="Apple SD Gothic Neo" pitchFamily="34" charset="-120"/>
               </a:rPr>
-              <a:t>TD가 무엇을 보낸다</a:t>
+              <a:t>TD는 Evidence를 준비한다</a:t>
             </a:r>
             <a:endParaRPr lang="en-US" sz="1530" dirty="0"/>
           </a:p>
@@ -1227,8 +1227,8 @@
         </p:nvSpPr>
         <p:spPr>
           <a:xfrm>
-            <a:off x="749808" y="2569464"/>
-            <a:ext cx="2468880" cy="1609344"/>
+            <a:off x="749808" y="2478024"/>
+            <a:ext cx="2468880" cy="1426464"/>
           </a:xfrm>
           <a:prstGeom prst="rect">
             <a:avLst/>
@@ -1254,7 +1254,7 @@
                 <a:ea typeface="Apple SD Gothic Neo" pitchFamily="34" charset="-122"/>
                 <a:cs typeface="Apple SD Gothic Neo" pitchFamily="34" charset="-120"/>
               </a:rPr>
-              <a:t>TD는 request context와 임시 키를 묶은 TDREPORT와 Quote를 만든다. QGS는 운반하고 TDQE가 Quote에 서명한다.</a:t>
+              <a:t>TD는 임시 키와 요청 문맥의 D를 TDREPORT에 넣는다. QGS daemon은 운반하고 TDQE가 TD Quote를 생성·서명한다.</a:t>
             </a:r>
             <a:endParaRPr lang="en-US" sz="1230" dirty="0"/>
           </a:p>
@@ -1268,8 +1268,181 @@
         </p:nvSpPr>
         <p:spPr>
           <a:xfrm>
-            <a:off x="4681728" y="1600200"/>
-            <a:ext cx="2834640" cy="2697480"/>
+            <a:off x="4681728" y="1508760"/>
+            <a:ext cx="2834640" cy="2514600"/>
+          </a:xfrm>
+          <a:prstGeom prst="roundRect">
+            <a:avLst/>
+          </a:prstGeom>
+          <a:solidFill>
+            <a:srgbClr val="1C64D1"/>
+          </a:solidFill>
+          <a:ln w="8890">
+            <a:solidFill>
+              <a:srgbClr val="1C64D1"/>
+            </a:solidFill>
+            <a:prstDash val="solid"/>
+          </a:ln>
+        </p:spPr>
+      </p:sp>
+      <p:sp>
+        <p:nvSpPr>
+          <p:cNvPr id="11" name="Shape 9"/>
+          <p:cNvSpPr/>
+          <p:nvPr/>
+        </p:nvSpPr>
+        <p:spPr>
+          <a:xfrm>
+            <a:off x="4846320" y="1673352"/>
+            <a:ext cx="1152144" cy="256032"/>
+          </a:xfrm>
+          <a:prstGeom prst="roundRect">
+            <a:avLst/>
+          </a:prstGeom>
+          <a:solidFill>
+            <a:srgbClr val="1650A8"/>
+          </a:solidFill>
+          <a:ln w="8890">
+            <a:solidFill>
+              <a:srgbClr val="1650A8"/>
+            </a:solidFill>
+            <a:prstDash val="solid"/>
+          </a:ln>
+        </p:spPr>
+      </p:sp>
+      <p:sp>
+        <p:nvSpPr>
+          <p:cNvPr id="12" name="Text 10"/>
+          <p:cNvSpPr/>
+          <p:nvPr/>
+        </p:nvSpPr>
+        <p:spPr>
+          <a:xfrm>
+            <a:off x="4846320" y="1741932"/>
+            <a:ext cx="1152144" cy="91440"/>
+          </a:xfrm>
+          <a:prstGeom prst="rect">
+            <a:avLst/>
+          </a:prstGeom>
+          <a:noFill/>
+          <a:ln/>
+        </p:spPr>
+        <p:txBody>
+          <a:bodyPr wrap="square" lIns="0" tIns="0" rIns="0" bIns="0" rtlCol="0" anchor="ctr">
+            <a:normAutofit/>
+          </a:bodyPr>
+          <a:lstStyle/>
+          <a:p>
+            <a:pPr algn="ctr" indent="0" marL="0">
+              <a:buNone/>
+            </a:pPr>
+            <a:r>
+              <a:rPr lang="en-US" sz="820" b="1" dirty="0">
+                <a:solidFill>
+                  <a:srgbClr val="FFFFFF"/>
+                </a:solidFill>
+                <a:latin typeface="Apple SD Gothic Neo" pitchFamily="34" charset="0"/>
+                <a:ea typeface="Apple SD Gothic Neo" pitchFamily="34" charset="-122"/>
+                <a:cs typeface="Apple SD Gothic Neo" pitchFamily="34" charset="-120"/>
+              </a:rPr>
+              <a:t>2 · RP/KMS</a:t>
+            </a:r>
+            <a:endParaRPr lang="en-US" sz="820" dirty="0"/>
+          </a:p>
+        </p:txBody>
+      </p:sp>
+      <p:sp>
+        <p:nvSpPr>
+          <p:cNvPr id="13" name="Text 11"/>
+          <p:cNvSpPr/>
+          <p:nvPr/>
+        </p:nvSpPr>
+        <p:spPr>
+          <a:xfrm>
+            <a:off x="4864608" y="2084832"/>
+            <a:ext cx="2468880" cy="256032"/>
+          </a:xfrm>
+          <a:prstGeom prst="rect">
+            <a:avLst/>
+          </a:prstGeom>
+          <a:noFill/>
+          <a:ln/>
+        </p:spPr>
+        <p:txBody>
+          <a:bodyPr wrap="square" lIns="0" tIns="0" rIns="0" bIns="0" rtlCol="0" anchor="ctr">
+            <a:normAutofit/>
+          </a:bodyPr>
+          <a:lstStyle/>
+          <a:p>
+            <a:pPr indent="0" marL="0">
+              <a:buNone/>
+            </a:pPr>
+            <a:r>
+              <a:rPr lang="en-US" sz="1530" b="1" dirty="0">
+                <a:solidFill>
+                  <a:srgbClr val="FFFFFF"/>
+                </a:solidFill>
+                <a:latin typeface="Apple SD Gothic Neo" pitchFamily="34" charset="0"/>
+                <a:ea typeface="Apple SD Gothic Neo" pitchFamily="34" charset="-122"/>
+                <a:cs typeface="Apple SD Gothic Neo" pitchFamily="34" charset="-120"/>
+              </a:rPr>
+              <a:t>RP/KMS는 전달하고 결정한다</a:t>
+            </a:r>
+            <a:endParaRPr lang="en-US" sz="1530" dirty="0"/>
+          </a:p>
+        </p:txBody>
+      </p:sp>
+      <p:sp>
+        <p:nvSpPr>
+          <p:cNvPr id="14" name="Text 12"/>
+          <p:cNvSpPr/>
+          <p:nvPr/>
+        </p:nvSpPr>
+        <p:spPr>
+          <a:xfrm>
+            <a:off x="4864608" y="2478024"/>
+            <a:ext cx="2468880" cy="1426464"/>
+          </a:xfrm>
+          <a:prstGeom prst="rect">
+            <a:avLst/>
+          </a:prstGeom>
+          <a:noFill/>
+          <a:ln/>
+        </p:spPr>
+        <p:txBody>
+          <a:bodyPr wrap="square" lIns="0" tIns="0" rIns="0" bIns="0" rtlCol="0" anchor="ctr">
+            <a:normAutofit/>
+          </a:bodyPr>
+          <a:lstStyle/>
+          <a:p>
+            <a:pPr indent="0" marL="0">
+              <a:buNone/>
+            </a:pPr>
+            <a:r>
+              <a:rPr lang="en-US" sz="1230" dirty="0">
+                <a:solidFill>
+                  <a:srgbClr val="FFFFFF"/>
+                </a:solidFill>
+                <a:latin typeface="Apple SD Gothic Neo" pitchFamily="34" charset="0"/>
+                <a:ea typeface="Apple SD Gothic Neo" pitchFamily="34" charset="-122"/>
+                <a:cs typeface="Apple SD Gothic Neo" pitchFamily="34" charset="-120"/>
+              </a:rPr>
+              <a:t>TD가 돌려준 Quote·key bytes·request를 Verifier에 보낸다. signed Result를 확인해도 아직 비밀을 바로 보내지 않는다.</a:t>
+            </a:r>
+            <a:endParaRPr lang="en-US" sz="1230" dirty="0"/>
+          </a:p>
+        </p:txBody>
+      </p:sp>
+      <p:sp>
+        <p:nvSpPr>
+          <p:cNvPr id="15" name="Shape 13"/>
+          <p:cNvSpPr/>
+          <p:nvPr/>
+        </p:nvSpPr>
+        <p:spPr>
+          <a:xfrm>
+            <a:off x="8796528" y="1508760"/>
+            <a:ext cx="2834640" cy="2514600"/>
           </a:xfrm>
           <a:prstGeom prst="roundRect">
             <a:avLst/>
@@ -1287,13 +1460,13 @@
       </p:sp>
       <p:sp>
         <p:nvSpPr>
-          <p:cNvPr id="11" name="Shape 9"/>
-          <p:cNvSpPr/>
-          <p:nvPr/>
-        </p:nvSpPr>
-        <p:spPr>
-          <a:xfrm>
-            <a:off x="4846320" y="1764792"/>
+          <p:cNvPr id="16" name="Shape 14"/>
+          <p:cNvSpPr/>
+          <p:nvPr/>
+        </p:nvSpPr>
+        <p:spPr>
+          <a:xfrm>
+            <a:off x="8961120" y="1673352"/>
             <a:ext cx="1152144" cy="256032"/>
           </a:xfrm>
           <a:prstGeom prst="roundRect">
@@ -1312,13 +1485,13 @@
       </p:sp>
       <p:sp>
         <p:nvSpPr>
-          <p:cNvPr id="12" name="Text 10"/>
-          <p:cNvSpPr/>
-          <p:nvPr/>
-        </p:nvSpPr>
-        <p:spPr>
-          <a:xfrm>
-            <a:off x="4846320" y="1833372"/>
+          <p:cNvPr id="17" name="Text 15"/>
+          <p:cNvSpPr/>
+          <p:nvPr/>
+        </p:nvSpPr>
+        <p:spPr>
+          <a:xfrm>
+            <a:off x="8961120" y="1741932"/>
             <a:ext cx="1152144" cy="91440"/>
           </a:xfrm>
           <a:prstGeom prst="rect">
@@ -1345,7 +1518,7 @@
                 <a:ea typeface="Apple SD Gothic Neo" pitchFamily="34" charset="-122"/>
                 <a:cs typeface="Apple SD Gothic Neo" pitchFamily="34" charset="-120"/>
               </a:rPr>
-              <a:t>2 · Verifier</a:t>
+              <a:t>3 · Verifier</a:t>
             </a:r>
             <a:endParaRPr lang="en-US" sz="820" dirty="0"/>
           </a:p>
@@ -1353,13 +1526,13 @@
       </p:sp>
       <p:sp>
         <p:nvSpPr>
-          <p:cNvPr id="13" name="Text 11"/>
-          <p:cNvSpPr/>
-          <p:nvPr/>
-        </p:nvSpPr>
-        <p:spPr>
-          <a:xfrm>
-            <a:off x="4864608" y="2176272"/>
+          <p:cNvPr id="18" name="Text 16"/>
+          <p:cNvSpPr/>
+          <p:nvPr/>
+        </p:nvSpPr>
+        <p:spPr>
+          <a:xfrm>
+            <a:off x="8979408" y="2084832"/>
             <a:ext cx="2468880" cy="256032"/>
           </a:xfrm>
           <a:prstGeom prst="rect">
@@ -1386,7 +1559,7 @@
                 <a:ea typeface="Apple SD Gothic Neo" pitchFamily="34" charset="-122"/>
                 <a:cs typeface="Apple SD Gothic Neo" pitchFamily="34" charset="-120"/>
               </a:rPr>
-              <a:t>Verifier가 무엇을 확인한다</a:t>
+              <a:t>Verifier는 평가해 Result를 서명한다</a:t>
             </a:r>
             <a:endParaRPr lang="en-US" sz="1530" dirty="0"/>
           </a:p>
@@ -1394,14 +1567,14 @@
       </p:sp>
       <p:sp>
         <p:nvSpPr>
-          <p:cNvPr id="14" name="Text 12"/>
-          <p:cNvSpPr/>
-          <p:nvPr/>
-        </p:nvSpPr>
-        <p:spPr>
-          <a:xfrm>
-            <a:off x="4864608" y="2569464"/>
-            <a:ext cx="2468880" cy="1609344"/>
+          <p:cNvPr id="19" name="Text 17"/>
+          <p:cNvSpPr/>
+          <p:nvPr/>
+        </p:nvSpPr>
+        <p:spPr>
+          <a:xfrm>
+            <a:off x="8979408" y="2478024"/>
+            <a:ext cx="2468880" cy="1426464"/>
           </a:xfrm>
           <a:prstGeom prst="rect">
             <a:avLst/>
@@ -1427,7 +1600,7 @@
                 <a:ea typeface="Apple SD Gothic Neo" pitchFamily="34" charset="-122"/>
                 <a:cs typeface="Apple SD Gothic Neo" pitchFamily="34" charset="-120"/>
               </a:rPr>
-              <a:t>Verifier는 Quote·collateral·request·key를 함께 확인해 signed Result를 만든다. Result는 아직 공개 명령이 아니다.</a:t>
+              <a:t>Verifier는 Quote·collateral·K/D/E·보관 문맥을 평가하고 signed Result를 RP/KMS에 돌려준다.</a:t>
             </a:r>
             <a:endParaRPr lang="en-US" sz="1230" dirty="0"/>
           </a:p>
@@ -1435,186 +1608,13 @@
       </p:sp>
       <p:sp>
         <p:nvSpPr>
-          <p:cNvPr id="15" name="Shape 13"/>
-          <p:cNvSpPr/>
-          <p:nvPr/>
-        </p:nvSpPr>
-        <p:spPr>
-          <a:xfrm>
-            <a:off x="8796528" y="1600200"/>
-            <a:ext cx="2834640" cy="2697480"/>
-          </a:xfrm>
-          <a:prstGeom prst="roundRect">
-            <a:avLst/>
-          </a:prstGeom>
-          <a:solidFill>
-            <a:srgbClr val="1C64D1"/>
-          </a:solidFill>
-          <a:ln w="8890">
-            <a:solidFill>
-              <a:srgbClr val="1C64D1"/>
-            </a:solidFill>
-            <a:prstDash val="solid"/>
-          </a:ln>
-        </p:spPr>
-      </p:sp>
-      <p:sp>
-        <p:nvSpPr>
-          <p:cNvPr id="16" name="Shape 14"/>
-          <p:cNvSpPr/>
-          <p:nvPr/>
-        </p:nvSpPr>
-        <p:spPr>
-          <a:xfrm>
-            <a:off x="8961120" y="1764792"/>
-            <a:ext cx="1152144" cy="256032"/>
-          </a:xfrm>
-          <a:prstGeom prst="roundRect">
-            <a:avLst/>
-          </a:prstGeom>
-          <a:solidFill>
-            <a:srgbClr val="1650A8"/>
-          </a:solidFill>
-          <a:ln w="8890">
-            <a:solidFill>
-              <a:srgbClr val="1650A8"/>
-            </a:solidFill>
-            <a:prstDash val="solid"/>
-          </a:ln>
-        </p:spPr>
-      </p:sp>
-      <p:sp>
-        <p:nvSpPr>
-          <p:cNvPr id="17" name="Text 15"/>
-          <p:cNvSpPr/>
-          <p:nvPr/>
-        </p:nvSpPr>
-        <p:spPr>
-          <a:xfrm>
-            <a:off x="8961120" y="1833372"/>
-            <a:ext cx="1152144" cy="91440"/>
-          </a:xfrm>
-          <a:prstGeom prst="rect">
-            <a:avLst/>
-          </a:prstGeom>
-          <a:noFill/>
-          <a:ln/>
-        </p:spPr>
-        <p:txBody>
-          <a:bodyPr wrap="square" lIns="0" tIns="0" rIns="0" bIns="0" rtlCol="0" anchor="ctr">
-            <a:normAutofit/>
-          </a:bodyPr>
-          <a:lstStyle/>
-          <a:p>
-            <a:pPr algn="ctr" indent="0" marL="0">
-              <a:buNone/>
-            </a:pPr>
-            <a:r>
-              <a:rPr lang="en-US" sz="820" b="1" dirty="0">
-                <a:solidFill>
-                  <a:srgbClr val="FFFFFF"/>
-                </a:solidFill>
-                <a:latin typeface="Apple SD Gothic Neo" pitchFamily="34" charset="0"/>
-                <a:ea typeface="Apple SD Gothic Neo" pitchFamily="34" charset="-122"/>
-                <a:cs typeface="Apple SD Gothic Neo" pitchFamily="34" charset="-120"/>
-              </a:rPr>
-              <a:t>3 · RP/KMS</a:t>
-            </a:r>
-            <a:endParaRPr lang="en-US" sz="820" dirty="0"/>
-          </a:p>
-        </p:txBody>
-      </p:sp>
-      <p:sp>
-        <p:nvSpPr>
-          <p:cNvPr id="18" name="Text 16"/>
-          <p:cNvSpPr/>
-          <p:nvPr/>
-        </p:nvSpPr>
-        <p:spPr>
-          <a:xfrm>
-            <a:off x="8979408" y="2176272"/>
-            <a:ext cx="2468880" cy="256032"/>
-          </a:xfrm>
-          <a:prstGeom prst="rect">
-            <a:avLst/>
-          </a:prstGeom>
-          <a:noFill/>
-          <a:ln/>
-        </p:spPr>
-        <p:txBody>
-          <a:bodyPr wrap="square" lIns="0" tIns="0" rIns="0" bIns="0" rtlCol="0" anchor="ctr">
-            <a:normAutofit/>
-          </a:bodyPr>
-          <a:lstStyle/>
-          <a:p>
-            <a:pPr indent="0" marL="0">
-              <a:buNone/>
-            </a:pPr>
-            <a:r>
-              <a:rPr lang="en-US" sz="1530" b="1" dirty="0">
-                <a:solidFill>
-                  <a:srgbClr val="FFFFFF"/>
-                </a:solidFill>
-                <a:latin typeface="Apple SD Gothic Neo" pitchFamily="34" charset="0"/>
-                <a:ea typeface="Apple SD Gothic Neo" pitchFamily="34" charset="-122"/>
-                <a:cs typeface="Apple SD Gothic Neo" pitchFamily="34" charset="-120"/>
-              </a:rPr>
-              <a:t>RP/KMS가 공개를 결정한다</a:t>
-            </a:r>
-            <a:endParaRPr lang="en-US" sz="1530" dirty="0"/>
-          </a:p>
-        </p:txBody>
-      </p:sp>
-      <p:sp>
-        <p:nvSpPr>
-          <p:cNvPr id="19" name="Text 17"/>
-          <p:cNvSpPr/>
-          <p:nvPr/>
-        </p:nvSpPr>
-        <p:spPr>
-          <a:xfrm>
-            <a:off x="8979408" y="2569464"/>
-            <a:ext cx="2468880" cy="1609344"/>
-          </a:xfrm>
-          <a:prstGeom prst="rect">
-            <a:avLst/>
-          </a:prstGeom>
-          <a:noFill/>
-          <a:ln/>
-        </p:spPr>
-        <p:txBody>
-          <a:bodyPr wrap="square" lIns="0" tIns="0" rIns="0" bIns="0" rtlCol="0" anchor="ctr">
-            <a:normAutofit/>
-          </a:bodyPr>
-          <a:lstStyle/>
-          <a:p>
-            <a:pPr indent="0" marL="0">
-              <a:buNone/>
-            </a:pPr>
-            <a:r>
-              <a:rPr lang="en-US" sz="1230" dirty="0">
-                <a:solidFill>
-                  <a:srgbClr val="FFFFFF"/>
-                </a:solidFill>
-                <a:latin typeface="Apple SD Gothic Neo" pitchFamily="34" charset="0"/>
-                <a:ea typeface="Apple SD Gothic Neo" pitchFamily="34" charset="-122"/>
-                <a:cs typeface="Apple SD Gothic Neo" pitchFamily="34" charset="-120"/>
-              </a:rPr>
-              <a:t>RP/KMS는 Result·시간·E/K·key possession을 다시 확인하고, allow일 때만 같은 key channel에 secret을 보낸다.</a:t>
-            </a:r>
-            <a:endParaRPr lang="en-US" sz="1230" dirty="0"/>
-          </a:p>
-        </p:txBody>
-      </p:sp>
-      <p:sp>
-        <p:nvSpPr>
           <p:cNvPr id="20" name="Shape 18"/>
           <p:cNvSpPr/>
           <p:nvPr/>
         </p:nvSpPr>
         <p:spPr>
           <a:xfrm>
-            <a:off x="3429000" y="2880360"/>
+            <a:off x="3429000" y="2788920"/>
             <a:ext cx="1216152" cy="0"/>
           </a:xfrm>
           <a:prstGeom prst="line">
@@ -1639,8 +1639,8 @@
         </p:nvSpPr>
         <p:spPr>
           <a:xfrm>
-            <a:off x="3383280" y="2587752"/>
-            <a:ext cx="1307592" cy="137160"/>
+            <a:off x="3218688" y="2496312"/>
+            <a:ext cx="1645920" cy="137160"/>
           </a:xfrm>
           <a:prstGeom prst="rect">
             <a:avLst/>
@@ -1658,7 +1658,7 @@
               <a:buNone/>
             </a:pPr>
             <a:r>
-              <a:rPr lang="en-US" sz="930" b="1" dirty="0">
+              <a:rPr lang="en-US" sz="890" b="1" dirty="0">
                 <a:solidFill>
                   <a:srgbClr val="B8F0F5"/>
                 </a:solidFill>
@@ -1666,9 +1666,9 @@
                 <a:ea typeface="Apple SD Gothic Neo" pitchFamily="34" charset="-122"/>
                 <a:cs typeface="Apple SD Gothic Neo" pitchFamily="34" charset="-120"/>
               </a:rPr>
-              <a:t>Evidence + key + context</a:t>
-            </a:r>
-            <a:endParaRPr lang="en-US" sz="930" dirty="0"/>
+              <a:t>Quote + key bytes + request</a:t>
+            </a:r>
+            <a:endParaRPr lang="en-US" sz="890" dirty="0"/>
           </a:p>
         </p:txBody>
       </p:sp>
@@ -1680,7 +1680,7 @@
         </p:nvSpPr>
         <p:spPr>
           <a:xfrm>
-            <a:off x="7543800" y="2880360"/>
+            <a:off x="7543800" y="2788920"/>
             <a:ext cx="1216152" cy="0"/>
           </a:xfrm>
           <a:prstGeom prst="line">
@@ -1705,8 +1705,8 @@
         </p:nvSpPr>
         <p:spPr>
           <a:xfrm>
-            <a:off x="7635240" y="2587752"/>
-            <a:ext cx="1024128" cy="137160"/>
+            <a:off x="7525512" y="2496312"/>
+            <a:ext cx="1234440" cy="137160"/>
           </a:xfrm>
           <a:prstGeom prst="rect">
             <a:avLst/>
@@ -1724,7 +1724,7 @@
               <a:buNone/>
             </a:pPr>
             <a:r>
-              <a:rPr lang="en-US" sz="930" b="1" dirty="0">
+              <a:rPr lang="en-US" sz="890" b="1" dirty="0">
                 <a:solidFill>
                   <a:srgbClr val="C5E1FF"/>
                 </a:solidFill>
@@ -1732,15 +1732,81 @@
                 <a:ea typeface="Apple SD Gothic Neo" pitchFamily="34" charset="-122"/>
                 <a:cs typeface="Apple SD Gothic Neo" pitchFamily="34" charset="-120"/>
               </a:rPr>
-              <a:t>signed Result</a:t>
-            </a:r>
-            <a:endParaRPr lang="en-US" sz="930" dirty="0"/>
+              <a:t>Evidence + K/D/E</a:t>
+            </a:r>
+            <a:endParaRPr lang="en-US" sz="890" dirty="0"/>
           </a:p>
         </p:txBody>
       </p:sp>
       <p:sp>
         <p:nvSpPr>
           <p:cNvPr id="24" name="Shape 22"/>
+          <p:cNvSpPr/>
+          <p:nvPr/>
+        </p:nvSpPr>
+        <p:spPr>
+          <a:xfrm>
+            <a:off x="8759952" y="4224528"/>
+            <a:ext cx="-1216152" cy="0"/>
+          </a:xfrm>
+          <a:prstGeom prst="line">
+            <a:avLst/>
+          </a:prstGeom>
+          <a:noFill/>
+          <a:ln w="27940">
+            <a:solidFill>
+              <a:srgbClr val="B8F0F5"/>
+            </a:solidFill>
+            <a:prstDash val="solid"/>
+            <a:headEnd type="none"/>
+            <a:tailEnd type="triangle"/>
+          </a:ln>
+        </p:spPr>
+      </p:sp>
+      <p:sp>
+        <p:nvSpPr>
+          <p:cNvPr id="25" name="Text 23"/>
+          <p:cNvSpPr/>
+          <p:nvPr/>
+        </p:nvSpPr>
+        <p:spPr>
+          <a:xfrm>
+            <a:off x="7589520" y="3968496"/>
+            <a:ext cx="1170432" cy="137160"/>
+          </a:xfrm>
+          <a:prstGeom prst="rect">
+            <a:avLst/>
+          </a:prstGeom>
+          <a:noFill/>
+          <a:ln/>
+        </p:spPr>
+        <p:txBody>
+          <a:bodyPr wrap="square" lIns="0" tIns="0" rIns="0" bIns="0" rtlCol="0" anchor="ctr">
+            <a:normAutofit/>
+          </a:bodyPr>
+          <a:lstStyle/>
+          <a:p>
+            <a:pPr algn="ctr" indent="0" marL="0">
+              <a:buNone/>
+            </a:pPr>
+            <a:r>
+              <a:rPr lang="en-US" sz="890" b="1" dirty="0">
+                <a:solidFill>
+                  <a:srgbClr val="B8F0F5"/>
+                </a:solidFill>
+                <a:latin typeface="Apple SD Gothic Neo" pitchFamily="34" charset="0"/>
+                <a:ea typeface="Apple SD Gothic Neo" pitchFamily="34" charset="-122"/>
+                <a:cs typeface="Apple SD Gothic Neo" pitchFamily="34" charset="-120"/>
+              </a:rPr>
+              <a:t>Verifier-signed Result</a:t>
+            </a:r>
+            <a:endParaRPr lang="en-US" sz="890" dirty="0"/>
+          </a:p>
+        </p:txBody>
+      </p:sp>
+      <p:sp>
+        <p:nvSpPr>
+          <p:cNvPr id="26" name="Shape 24"/>
           <p:cNvSpPr/>
           <p:nvPr/>
         </p:nvSpPr>
@@ -1765,7 +1831,7 @@
       </p:sp>
       <p:sp>
         <p:nvSpPr>
-          <p:cNvPr id="25" name="Shape 23"/>
+          <p:cNvPr id="27" name="Shape 25"/>
           <p:cNvSpPr/>
           <p:nvPr/>
         </p:nvSpPr>
@@ -1790,7 +1856,7 @@
       </p:sp>
       <p:sp>
         <p:nvSpPr>
-          <p:cNvPr id="26" name="Text 24"/>
+          <p:cNvPr id="28" name="Text 26"/>
           <p:cNvSpPr/>
           <p:nvPr/>
         </p:nvSpPr>
@@ -1831,7 +1897,7 @@
       </p:sp>
       <p:sp>
         <p:nvSpPr>
-          <p:cNvPr id="27" name="Text 25"/>
+          <p:cNvPr id="29" name="Text 27"/>
           <p:cNvSpPr/>
           <p:nvPr/>
         </p:nvSpPr>
@@ -1864,7 +1930,7 @@
                 <a:ea typeface="Apple SD Gothic Neo" pitchFamily="34" charset="-122"/>
                 <a:cs typeface="Apple SD Gothic Neo" pitchFamily="34" charset="-120"/>
               </a:rPr>
-              <a:t>Verifier가 Evidence를 평가해도 secret을 공개하지는 않는다. 공개 권한은 RP/KMS가 자신의 release policy로 Result를 확인한 뒤에만 행사한다.</a:t>
+              <a:t>Verifier가 Evidence를 평가해도 secret을 공개하지는 않는다. RP/KMS가 Result·시간·E/K·키 소유 증명을 다시 확인한 allow path에서만 같은 승인 키 channel로 secret을 전달한다.</a:t>
             </a:r>
             <a:endParaRPr lang="en-US" sz="1330" dirty="0"/>
           </a:p>
@@ -1872,7 +1938,7 @@
       </p:sp>
       <p:sp>
         <p:nvSpPr>
-          <p:cNvPr id="28" name="Shape 26"/>
+          <p:cNvPr id="30" name="Shape 28"/>
           <p:cNvSpPr/>
           <p:nvPr/>
         </p:nvSpPr>
@@ -1897,7 +1963,7 @@
       </p:sp>
       <p:sp>
         <p:nvSpPr>
-          <p:cNvPr id="29" name="Text 27"/>
+          <p:cNvPr id="31" name="Text 29"/>
           <p:cNvSpPr/>
           <p:nvPr/>
         </p:nvSpPr>
@@ -1938,7 +2004,7 @@
       </p:sp>
       <p:sp>
         <p:nvSpPr>
-          <p:cNvPr id="30" name="Shape 28"/>
+          <p:cNvPr id="32" name="Shape 30"/>
           <p:cNvSpPr/>
           <p:nvPr/>
         </p:nvSpPr>
@@ -1963,7 +2029,7 @@
       </p:sp>
       <p:sp>
         <p:nvSpPr>
-          <p:cNvPr id="31" name="Text 29"/>
+          <p:cNvPr id="33" name="Text 31"/>
           <p:cNvSpPr/>
           <p:nvPr/>
         </p:nvSpPr>
@@ -2004,7 +2070,7 @@
       </p:sp>
       <p:sp>
         <p:nvSpPr>
-          <p:cNvPr id="32" name="Shape 30"/>
+          <p:cNvPr id="34" name="Shape 32"/>
           <p:cNvSpPr/>
           <p:nvPr/>
         </p:nvSpPr>
@@ -2027,7 +2093,7 @@
       </p:sp>
       <p:sp>
         <p:nvSpPr>
-          <p:cNvPr id="33" name="Text 31"/>
+          <p:cNvPr id="35" name="Text 33"/>
           <p:cNvSpPr/>
           <p:nvPr/>
         </p:nvSpPr>
@@ -2060,7 +2126,7 @@
                 <a:ea typeface="Apple SD Gothic Neo" pitchFamily="34" charset="-122"/>
                 <a:cs typeface="Apple SD Gothic Neo" pitchFamily="34" charset="-120"/>
               </a:rPr>
-              <a:t>C-001 · C-004 · C-007 · B-004/B-006 · summary must-see</a:t>
+              <a:t>C-001 · C-004 · C-007 · E-012/E-013/E-015/E-018 · B-004/B-006 · 〔S-002,S-003〕</a:t>
             </a:r>
             <a:endParaRPr lang="en-US" sz="780" dirty="0"/>
           </a:p>
@@ -2068,7 +2134,7 @@
       </p:sp>
       <p:sp>
         <p:nvSpPr>
-          <p:cNvPr id="34" name="Text 32"/>
+          <p:cNvPr id="36" name="Text 34"/>
           <p:cNvSpPr/>
           <p:nvPr/>
         </p:nvSpPr>
@@ -2101,7 +2167,7 @@
                 <a:ea typeface="Apple SD Gothic Neo" pitchFamily="34" charset="-122"/>
                 <a:cs typeface="Apple SD Gothic Neo" pitchFamily="34" charset="-120"/>
               </a:rPr>
-              <a:t>Sources: RFC 9334 · Intel DCAP / TDX documentation</a:t>
+              <a:t>Source markers: 〔S-…〕 · Appendix 16</a:t>
             </a:r>
             <a:endParaRPr lang="en-US" sz="780" dirty="0"/>
           </a:p>
@@ -2174,7 +2240,7 @@
                 <a:ea typeface="Apple SD Gothic Neo" pitchFamily="34" charset="-122"/>
                 <a:cs typeface="Apple SD Gothic Neo" pitchFamily="34" charset="-120"/>
               </a:rPr>
-              <a:t>비밀은 “검증 성공” 뒤에도 두 번 더 확인한 뒤에만 공개된다</a:t>
+              <a:t>비밀 공개는 여섯 단계가 모두 닫힐 때만 일어난다</a:t>
             </a:r>
             <a:endParaRPr lang="en-US" sz="2900" dirty="0"/>
           </a:p>
@@ -2215,7 +2281,7 @@
                 <a:ea typeface="Apple SD Gothic Neo" pitchFamily="34" charset="-122"/>
                 <a:cs typeface="Apple SD Gothic Neo" pitchFamily="34" charset="-120"/>
               </a:rPr>
-              <a:t>request binding → Quote → appraisal Result → PoP → same-key release의 순서를 한 개의 닫힌 path로 읽는다.</a:t>
+              <a:t>처음 읽을 때는 K·D·E와 키 소유 증명(PoP)의 뜻을 먼저 잡고, request binding부터 same-key release까지 순서대로 읽는다.</a:t>
             </a:r>
             <a:endParaRPr lang="en-US" sz="1430" dirty="0"/>
           </a:p>
@@ -2270,8 +2336,436 @@
         </p:nvSpPr>
         <p:spPr>
           <a:xfrm>
-            <a:off x="530352" y="1600200"/>
-            <a:ext cx="2487168" cy="3429000"/>
+            <a:off x="502920" y="1298448"/>
+            <a:ext cx="2670048" cy="594360"/>
+          </a:xfrm>
+          <a:prstGeom prst="roundRect">
+            <a:avLst/>
+          </a:prstGeom>
+          <a:solidFill>
+            <a:srgbClr val="E8F5FA"/>
+          </a:solidFill>
+          <a:ln w="8890">
+            <a:solidFill>
+              <a:srgbClr val="E8F5FA"/>
+            </a:solidFill>
+            <a:prstDash val="solid"/>
+          </a:ln>
+        </p:spPr>
+      </p:sp>
+      <p:sp>
+        <p:nvSpPr>
+          <p:cNvPr id="6" name="Text 4"/>
+          <p:cNvSpPr/>
+          <p:nvPr/>
+        </p:nvSpPr>
+        <p:spPr>
+          <a:xfrm>
+            <a:off x="649224" y="1499616"/>
+            <a:ext cx="420624" cy="128016"/>
+          </a:xfrm>
+          <a:prstGeom prst="rect">
+            <a:avLst/>
+          </a:prstGeom>
+          <a:noFill/>
+          <a:ln/>
+        </p:spPr>
+        <p:txBody>
+          <a:bodyPr wrap="square" lIns="0" tIns="0" rIns="0" bIns="0" rtlCol="0" anchor="ctr">
+            <a:normAutofit/>
+          </a:bodyPr>
+          <a:lstStyle/>
+          <a:p>
+            <a:pPr indent="0" marL="0">
+              <a:buNone/>
+            </a:pPr>
+            <a:r>
+              <a:rPr lang="en-US" sz="1150" b="1" dirty="0">
+                <a:solidFill>
+                  <a:srgbClr val="0B7890"/>
+                </a:solidFill>
+                <a:latin typeface="Apple SD Gothic Neo" pitchFamily="34" charset="0"/>
+                <a:ea typeface="Apple SD Gothic Neo" pitchFamily="34" charset="-122"/>
+                <a:cs typeface="Apple SD Gothic Neo" pitchFamily="34" charset="-120"/>
+              </a:rPr>
+              <a:t>K</a:t>
+            </a:r>
+            <a:endParaRPr lang="en-US" sz="1150" dirty="0"/>
+          </a:p>
+        </p:txBody>
+      </p:sp>
+      <p:sp>
+        <p:nvSpPr>
+          <p:cNvPr id="7" name="Text 5"/>
+          <p:cNvSpPr/>
+          <p:nvPr/>
+        </p:nvSpPr>
+        <p:spPr>
+          <a:xfrm>
+            <a:off x="1097280" y="1499616"/>
+            <a:ext cx="1901952" cy="128016"/>
+          </a:xfrm>
+          <a:prstGeom prst="rect">
+            <a:avLst/>
+          </a:prstGeom>
+          <a:noFill/>
+          <a:ln/>
+        </p:spPr>
+        <p:txBody>
+          <a:bodyPr wrap="square" lIns="0" tIns="0" rIns="0" bIns="0" rtlCol="0" anchor="ctr">
+            <a:normAutofit/>
+          </a:bodyPr>
+          <a:lstStyle/>
+          <a:p>
+            <a:pPr indent="0" marL="0">
+              <a:buNone/>
+            </a:pPr>
+            <a:r>
+              <a:rPr lang="en-US" sz="980" dirty="0">
+                <a:solidFill>
+                  <a:srgbClr val="14273A"/>
+                </a:solidFill>
+                <a:latin typeface="Apple SD Gothic Neo" pitchFamily="34" charset="0"/>
+                <a:ea typeface="Apple SD Gothic Neo" pitchFamily="34" charset="-122"/>
+                <a:cs typeface="Apple SD Gothic Neo" pitchFamily="34" charset="-120"/>
+              </a:rPr>
+              <a:t>승인할 공개키의 digest</a:t>
+            </a:r>
+            <a:endParaRPr lang="en-US" sz="980" dirty="0"/>
+          </a:p>
+        </p:txBody>
+      </p:sp>
+      <p:sp>
+        <p:nvSpPr>
+          <p:cNvPr id="8" name="Shape 6"/>
+          <p:cNvSpPr/>
+          <p:nvPr/>
+        </p:nvSpPr>
+        <p:spPr>
+          <a:xfrm>
+            <a:off x="3410712" y="1298448"/>
+            <a:ext cx="2670048" cy="594360"/>
+          </a:xfrm>
+          <a:prstGeom prst="roundRect">
+            <a:avLst/>
+          </a:prstGeom>
+          <a:solidFill>
+            <a:srgbClr val="E8F5FA"/>
+          </a:solidFill>
+          <a:ln w="8890">
+            <a:solidFill>
+              <a:srgbClr val="E8F5FA"/>
+            </a:solidFill>
+            <a:prstDash val="solid"/>
+          </a:ln>
+        </p:spPr>
+      </p:sp>
+      <p:sp>
+        <p:nvSpPr>
+          <p:cNvPr id="9" name="Text 7"/>
+          <p:cNvSpPr/>
+          <p:nvPr/>
+        </p:nvSpPr>
+        <p:spPr>
+          <a:xfrm>
+            <a:off x="3557016" y="1499616"/>
+            <a:ext cx="420624" cy="128016"/>
+          </a:xfrm>
+          <a:prstGeom prst="rect">
+            <a:avLst/>
+          </a:prstGeom>
+          <a:noFill/>
+          <a:ln/>
+        </p:spPr>
+        <p:txBody>
+          <a:bodyPr wrap="square" lIns="0" tIns="0" rIns="0" bIns="0" rtlCol="0" anchor="ctr">
+            <a:normAutofit/>
+          </a:bodyPr>
+          <a:lstStyle/>
+          <a:p>
+            <a:pPr indent="0" marL="0">
+              <a:buNone/>
+            </a:pPr>
+            <a:r>
+              <a:rPr lang="en-US" sz="1150" b="1" dirty="0">
+                <a:solidFill>
+                  <a:srgbClr val="0B7890"/>
+                </a:solidFill>
+                <a:latin typeface="Apple SD Gothic Neo" pitchFamily="34" charset="0"/>
+                <a:ea typeface="Apple SD Gothic Neo" pitchFamily="34" charset="-122"/>
+                <a:cs typeface="Apple SD Gothic Neo" pitchFamily="34" charset="-120"/>
+              </a:rPr>
+              <a:t>D</a:t>
+            </a:r>
+            <a:endParaRPr lang="en-US" sz="1150" dirty="0"/>
+          </a:p>
+        </p:txBody>
+      </p:sp>
+      <p:sp>
+        <p:nvSpPr>
+          <p:cNvPr id="10" name="Text 8"/>
+          <p:cNvSpPr/>
+          <p:nvPr/>
+        </p:nvSpPr>
+        <p:spPr>
+          <a:xfrm>
+            <a:off x="4005072" y="1499616"/>
+            <a:ext cx="1901952" cy="128016"/>
+          </a:xfrm>
+          <a:prstGeom prst="rect">
+            <a:avLst/>
+          </a:prstGeom>
+          <a:noFill/>
+          <a:ln/>
+        </p:spPr>
+        <p:txBody>
+          <a:bodyPr wrap="square" lIns="0" tIns="0" rIns="0" bIns="0" rtlCol="0" anchor="ctr">
+            <a:normAutofit/>
+          </a:bodyPr>
+          <a:lstStyle/>
+          <a:p>
+            <a:pPr indent="0" marL="0">
+              <a:buNone/>
+            </a:pPr>
+            <a:r>
+              <a:rPr lang="en-US" sz="980" dirty="0">
+                <a:solidFill>
+                  <a:srgbClr val="14273A"/>
+                </a:solidFill>
+                <a:latin typeface="Apple SD Gothic Neo" pitchFamily="34" charset="0"/>
+                <a:ea typeface="Apple SD Gothic Neo" pitchFamily="34" charset="-122"/>
+                <a:cs typeface="Apple SD Gothic Neo" pitchFamily="34" charset="-120"/>
+              </a:rPr>
+              <a:t>요청 문맥과 K를 묶은 digest</a:t>
+            </a:r>
+            <a:endParaRPr lang="en-US" sz="980" dirty="0"/>
+          </a:p>
+        </p:txBody>
+      </p:sp>
+      <p:sp>
+        <p:nvSpPr>
+          <p:cNvPr id="11" name="Shape 9"/>
+          <p:cNvSpPr/>
+          <p:nvPr/>
+        </p:nvSpPr>
+        <p:spPr>
+          <a:xfrm>
+            <a:off x="6318504" y="1298448"/>
+            <a:ext cx="2670048" cy="594360"/>
+          </a:xfrm>
+          <a:prstGeom prst="roundRect">
+            <a:avLst/>
+          </a:prstGeom>
+          <a:solidFill>
+            <a:srgbClr val="E8F5FA"/>
+          </a:solidFill>
+          <a:ln w="8890">
+            <a:solidFill>
+              <a:srgbClr val="E8F5FA"/>
+            </a:solidFill>
+            <a:prstDash val="solid"/>
+          </a:ln>
+        </p:spPr>
+      </p:sp>
+      <p:sp>
+        <p:nvSpPr>
+          <p:cNvPr id="12" name="Text 10"/>
+          <p:cNvSpPr/>
+          <p:nvPr/>
+        </p:nvSpPr>
+        <p:spPr>
+          <a:xfrm>
+            <a:off x="6464808" y="1499616"/>
+            <a:ext cx="420624" cy="128016"/>
+          </a:xfrm>
+          <a:prstGeom prst="rect">
+            <a:avLst/>
+          </a:prstGeom>
+          <a:noFill/>
+          <a:ln/>
+        </p:spPr>
+        <p:txBody>
+          <a:bodyPr wrap="square" lIns="0" tIns="0" rIns="0" bIns="0" rtlCol="0" anchor="ctr">
+            <a:normAutofit/>
+          </a:bodyPr>
+          <a:lstStyle/>
+          <a:p>
+            <a:pPr indent="0" marL="0">
+              <a:buNone/>
+            </a:pPr>
+            <a:r>
+              <a:rPr lang="en-US" sz="1150" b="1" dirty="0">
+                <a:solidFill>
+                  <a:srgbClr val="0B7890"/>
+                </a:solidFill>
+                <a:latin typeface="Apple SD Gothic Neo" pitchFamily="34" charset="0"/>
+                <a:ea typeface="Apple SD Gothic Neo" pitchFamily="34" charset="-122"/>
+                <a:cs typeface="Apple SD Gothic Neo" pitchFamily="34" charset="-120"/>
+              </a:rPr>
+              <a:t>E</a:t>
+            </a:r>
+            <a:endParaRPr lang="en-US" sz="1150" dirty="0"/>
+          </a:p>
+        </p:txBody>
+      </p:sp>
+      <p:sp>
+        <p:nvSpPr>
+          <p:cNvPr id="13" name="Text 11"/>
+          <p:cNvSpPr/>
+          <p:nvPr/>
+        </p:nvSpPr>
+        <p:spPr>
+          <a:xfrm>
+            <a:off x="6912864" y="1499616"/>
+            <a:ext cx="1901952" cy="128016"/>
+          </a:xfrm>
+          <a:prstGeom prst="rect">
+            <a:avLst/>
+          </a:prstGeom>
+          <a:noFill/>
+          <a:ln/>
+        </p:spPr>
+        <p:txBody>
+          <a:bodyPr wrap="square" lIns="0" tIns="0" rIns="0" bIns="0" rtlCol="0" anchor="ctr">
+            <a:normAutofit/>
+          </a:bodyPr>
+          <a:lstStyle/>
+          <a:p>
+            <a:pPr indent="0" marL="0">
+              <a:buNone/>
+            </a:pPr>
+            <a:r>
+              <a:rPr lang="en-US" sz="980" dirty="0">
+                <a:solidFill>
+                  <a:srgbClr val="14273A"/>
+                </a:solidFill>
+                <a:latin typeface="Apple SD Gothic Neo" pitchFamily="34" charset="0"/>
+                <a:ea typeface="Apple SD Gothic Neo" pitchFamily="34" charset="-122"/>
+                <a:cs typeface="Apple SD Gothic Neo" pitchFamily="34" charset="-120"/>
+              </a:rPr>
+              <a:t>정확한 Quote 원문의 digest</a:t>
+            </a:r>
+            <a:endParaRPr lang="en-US" sz="980" dirty="0"/>
+          </a:p>
+        </p:txBody>
+      </p:sp>
+      <p:sp>
+        <p:nvSpPr>
+          <p:cNvPr id="14" name="Shape 12"/>
+          <p:cNvSpPr/>
+          <p:nvPr/>
+        </p:nvSpPr>
+        <p:spPr>
+          <a:xfrm>
+            <a:off x="9226296" y="1298448"/>
+            <a:ext cx="2670048" cy="594360"/>
+          </a:xfrm>
+          <a:prstGeom prst="roundRect">
+            <a:avLst/>
+          </a:prstGeom>
+          <a:solidFill>
+            <a:srgbClr val="F3EEFF"/>
+          </a:solidFill>
+          <a:ln w="8890">
+            <a:solidFill>
+              <a:srgbClr val="F3EEFF"/>
+            </a:solidFill>
+            <a:prstDash val="solid"/>
+          </a:ln>
+        </p:spPr>
+      </p:sp>
+      <p:sp>
+        <p:nvSpPr>
+          <p:cNvPr id="15" name="Text 13"/>
+          <p:cNvSpPr/>
+          <p:nvPr/>
+        </p:nvSpPr>
+        <p:spPr>
+          <a:xfrm>
+            <a:off x="9372600" y="1499616"/>
+            <a:ext cx="420624" cy="128016"/>
+          </a:xfrm>
+          <a:prstGeom prst="rect">
+            <a:avLst/>
+          </a:prstGeom>
+          <a:noFill/>
+          <a:ln/>
+        </p:spPr>
+        <p:txBody>
+          <a:bodyPr wrap="square" lIns="0" tIns="0" rIns="0" bIns="0" rtlCol="0" anchor="ctr">
+            <a:normAutofit/>
+          </a:bodyPr>
+          <a:lstStyle/>
+          <a:p>
+            <a:pPr indent="0" marL="0">
+              <a:buNone/>
+            </a:pPr>
+            <a:r>
+              <a:rPr lang="en-US" sz="1150" b="1" dirty="0">
+                <a:solidFill>
+                  <a:srgbClr val="7044C8"/>
+                </a:solidFill>
+                <a:latin typeface="Apple SD Gothic Neo" pitchFamily="34" charset="0"/>
+                <a:ea typeface="Apple SD Gothic Neo" pitchFamily="34" charset="-122"/>
+                <a:cs typeface="Apple SD Gothic Neo" pitchFamily="34" charset="-120"/>
+              </a:rPr>
+              <a:t>PoP</a:t>
+            </a:r>
+            <a:endParaRPr lang="en-US" sz="1150" dirty="0"/>
+          </a:p>
+        </p:txBody>
+      </p:sp>
+      <p:sp>
+        <p:nvSpPr>
+          <p:cNvPr id="16" name="Text 14"/>
+          <p:cNvSpPr/>
+          <p:nvPr/>
+        </p:nvSpPr>
+        <p:spPr>
+          <a:xfrm>
+            <a:off x="9820656" y="1499616"/>
+            <a:ext cx="1901952" cy="128016"/>
+          </a:xfrm>
+          <a:prstGeom prst="rect">
+            <a:avLst/>
+          </a:prstGeom>
+          <a:noFill/>
+          <a:ln/>
+        </p:spPr>
+        <p:txBody>
+          <a:bodyPr wrap="square" lIns="0" tIns="0" rIns="0" bIns="0" rtlCol="0" anchor="ctr">
+            <a:normAutofit/>
+          </a:bodyPr>
+          <a:lstStyle/>
+          <a:p>
+            <a:pPr indent="0" marL="0">
+              <a:buNone/>
+            </a:pPr>
+            <a:r>
+              <a:rPr lang="en-US" sz="980" dirty="0">
+                <a:solidFill>
+                  <a:srgbClr val="14273A"/>
+                </a:solidFill>
+                <a:latin typeface="Apple SD Gothic Neo" pitchFamily="34" charset="0"/>
+                <a:ea typeface="Apple SD Gothic Neo" pitchFamily="34" charset="-122"/>
+                <a:cs typeface="Apple SD Gothic Neo" pitchFamily="34" charset="-120"/>
+              </a:rPr>
+              <a:t>키 소유 증명(Proof of Possession)</a:t>
+            </a:r>
+            <a:endParaRPr lang="en-US" sz="980" dirty="0"/>
+          </a:p>
+        </p:txBody>
+      </p:sp>
+      <p:sp>
+        <p:nvSpPr>
+          <p:cNvPr id="17" name="Shape 15"/>
+          <p:cNvSpPr/>
+          <p:nvPr/>
+        </p:nvSpPr>
+        <p:spPr>
+          <a:xfrm>
+            <a:off x="384048" y="2212848"/>
+            <a:ext cx="1755648" cy="2514600"/>
           </a:xfrm>
           <a:prstGeom prst="roundRect">
             <a:avLst/>
@@ -2289,13 +2783,13 @@
       </p:sp>
       <p:sp>
         <p:nvSpPr>
-          <p:cNvPr id="6" name="Shape 4"/>
-          <p:cNvSpPr/>
-          <p:nvPr/>
-        </p:nvSpPr>
-        <p:spPr>
-          <a:xfrm>
-            <a:off x="694944" y="1764792"/>
+          <p:cNvPr id="18" name="Shape 16"/>
+          <p:cNvSpPr/>
+          <p:nvPr/>
+        </p:nvSpPr>
+        <p:spPr>
+          <a:xfrm>
+            <a:off x="548640" y="2377440"/>
             <a:ext cx="1152144" cy="256032"/>
           </a:xfrm>
           <a:prstGeom prst="roundRect">
@@ -2314,13 +2808,13 @@
       </p:sp>
       <p:sp>
         <p:nvSpPr>
-          <p:cNvPr id="7" name="Text 5"/>
-          <p:cNvSpPr/>
-          <p:nvPr/>
-        </p:nvSpPr>
-        <p:spPr>
-          <a:xfrm>
-            <a:off x="694944" y="1833372"/>
+          <p:cNvPr id="19" name="Text 17"/>
+          <p:cNvSpPr/>
+          <p:nvPr/>
+        </p:nvSpPr>
+        <p:spPr>
+          <a:xfrm>
+            <a:off x="548640" y="2446020"/>
             <a:ext cx="1152144" cy="91440"/>
           </a:xfrm>
           <a:prstGeom prst="rect">
@@ -2355,14 +2849,14 @@
       </p:sp>
       <p:sp>
         <p:nvSpPr>
-          <p:cNvPr id="8" name="Text 6"/>
-          <p:cNvSpPr/>
-          <p:nvPr/>
-        </p:nvSpPr>
-        <p:spPr>
-          <a:xfrm>
-            <a:off x="713232" y="2176272"/>
-            <a:ext cx="2121408" cy="256032"/>
+          <p:cNvPr id="20" name="Text 18"/>
+          <p:cNvSpPr/>
+          <p:nvPr/>
+        </p:nvSpPr>
+        <p:spPr>
+          <a:xfrm>
+            <a:off x="566928" y="2788920"/>
+            <a:ext cx="1389888" cy="256032"/>
           </a:xfrm>
           <a:prstGeom prst="rect">
             <a:avLst/>
@@ -2388,7 +2882,7 @@
                 <a:ea typeface="Apple SD Gothic Neo" pitchFamily="34" charset="-122"/>
                 <a:cs typeface="Apple SD Gothic Neo" pitchFamily="34" charset="-120"/>
               </a:rPr>
-              <a:t>요청을 묶는다</a:t>
+              <a:t>요청 결합</a:t>
             </a:r>
             <a:endParaRPr lang="en-US" sz="1530" dirty="0"/>
           </a:p>
@@ -2396,14 +2890,14 @@
       </p:sp>
       <p:sp>
         <p:nvSpPr>
-          <p:cNvPr id="9" name="Text 7"/>
-          <p:cNvSpPr/>
-          <p:nvPr/>
-        </p:nvSpPr>
-        <p:spPr>
-          <a:xfrm>
-            <a:off x="713232" y="2569464"/>
-            <a:ext cx="2121408" cy="2340864"/>
+          <p:cNvPr id="21" name="Text 19"/>
+          <p:cNvSpPr/>
+          <p:nvPr/>
+        </p:nvSpPr>
+        <p:spPr>
+          <a:xfrm>
+            <a:off x="566928" y="3182112"/>
+            <a:ext cx="1389888" cy="1426464"/>
           </a:xfrm>
           <a:prstGeom prst="rect">
             <a:avLst/>
@@ -2429,28 +2923,45 @@
                 <a:ea typeface="Apple SD Gothic Neo" pitchFamily="34" charset="-122"/>
                 <a:cs typeface="Apple SD Gothic Neo" pitchFamily="34" charset="-120"/>
               </a:rPr>
-              <a:t>RP/KMS가 request ID·subject·audience를 보내고, Verifier는 nonce와 기대 문맥을 보관한다.</a:t>
+              <a:t>RP/KMS 요청</a:t>
             </a:r>
             <a:endParaRPr lang="en-US" sz="1230" dirty="0"/>
           </a:p>
-        </p:txBody>
-      </p:sp>
-      <p:sp>
-        <p:nvSpPr>
-          <p:cNvPr id="10" name="Shape 8"/>
-          <p:cNvSpPr/>
-          <p:nvPr/>
-        </p:nvSpPr>
-        <p:spPr>
-          <a:xfrm>
-            <a:off x="3054096" y="3246120"/>
-            <a:ext cx="310896" cy="0"/>
+          <a:p>
+            <a:pPr indent="0" marL="0">
+              <a:buNone/>
+            </a:pPr>
+            <a:r>
+              <a:rPr lang="en-US" sz="1230" dirty="0">
+                <a:solidFill>
+                  <a:srgbClr val="14273A"/>
+                </a:solidFill>
+                <a:latin typeface="Apple SD Gothic Neo" pitchFamily="34" charset="0"/>
+                <a:ea typeface="Apple SD Gothic Neo" pitchFamily="34" charset="-122"/>
+                <a:cs typeface="Apple SD Gothic Neo" pitchFamily="34" charset="-120"/>
+              </a:rPr>
+              <a:t>Verifier nonce 보관</a:t>
+            </a:r>
+            <a:endParaRPr lang="en-US" sz="1230" dirty="0"/>
+          </a:p>
+        </p:txBody>
+      </p:sp>
+      <p:sp>
+        <p:nvSpPr>
+          <p:cNvPr id="22" name="Shape 20"/>
+          <p:cNvSpPr/>
+          <p:nvPr/>
+        </p:nvSpPr>
+        <p:spPr>
+          <a:xfrm>
+            <a:off x="2167128" y="3337560"/>
+            <a:ext cx="137160" cy="0"/>
           </a:xfrm>
           <a:prstGeom prst="line">
             <a:avLst/>
           </a:prstGeom>
           <a:noFill/>
-          <a:ln w="22860">
+          <a:ln w="19050">
             <a:solidFill>
               <a:srgbClr val="1C64D1"/>
             </a:solidFill>
@@ -2462,14 +2973,14 @@
       </p:sp>
       <p:sp>
         <p:nvSpPr>
-          <p:cNvPr id="11" name="Shape 9"/>
-          <p:cNvSpPr/>
-          <p:nvPr/>
-        </p:nvSpPr>
-        <p:spPr>
-          <a:xfrm>
-            <a:off x="3419856" y="1600200"/>
-            <a:ext cx="2487168" cy="3429000"/>
+          <p:cNvPr id="23" name="Shape 21"/>
+          <p:cNvSpPr/>
+          <p:nvPr/>
+        </p:nvSpPr>
+        <p:spPr>
+          <a:xfrm>
+            <a:off x="2340864" y="2212848"/>
+            <a:ext cx="1755648" cy="2514600"/>
           </a:xfrm>
           <a:prstGeom prst="roundRect">
             <a:avLst/>
@@ -2487,13 +2998,228 @@
       </p:sp>
       <p:sp>
         <p:nvSpPr>
-          <p:cNvPr id="12" name="Shape 10"/>
-          <p:cNvSpPr/>
-          <p:nvPr/>
-        </p:nvSpPr>
-        <p:spPr>
-          <a:xfrm>
-            <a:off x="3584448" y="1764792"/>
+          <p:cNvPr id="24" name="Shape 22"/>
+          <p:cNvSpPr/>
+          <p:nvPr/>
+        </p:nvSpPr>
+        <p:spPr>
+          <a:xfrm>
+            <a:off x="2505456" y="2377440"/>
+            <a:ext cx="1152144" cy="256032"/>
+          </a:xfrm>
+          <a:prstGeom prst="roundRect">
+            <a:avLst/>
+          </a:prstGeom>
+          <a:solidFill>
+            <a:srgbClr val="7044C8"/>
+          </a:solidFill>
+          <a:ln w="8890">
+            <a:solidFill>
+              <a:srgbClr val="7044C8"/>
+            </a:solidFill>
+            <a:prstDash val="solid"/>
+          </a:ln>
+        </p:spPr>
+      </p:sp>
+      <p:sp>
+        <p:nvSpPr>
+          <p:cNvPr id="25" name="Text 23"/>
+          <p:cNvSpPr/>
+          <p:nvPr/>
+        </p:nvSpPr>
+        <p:spPr>
+          <a:xfrm>
+            <a:off x="2505456" y="2446020"/>
+            <a:ext cx="1152144" cy="91440"/>
+          </a:xfrm>
+          <a:prstGeom prst="rect">
+            <a:avLst/>
+          </a:prstGeom>
+          <a:noFill/>
+          <a:ln/>
+        </p:spPr>
+        <p:txBody>
+          <a:bodyPr wrap="square" lIns="0" tIns="0" rIns="0" bIns="0" rtlCol="0" anchor="ctr">
+            <a:normAutofit/>
+          </a:bodyPr>
+          <a:lstStyle/>
+          <a:p>
+            <a:pPr algn="ctr" indent="0" marL="0">
+              <a:buNone/>
+            </a:pPr>
+            <a:r>
+              <a:rPr lang="en-US" sz="820" b="1" dirty="0">
+                <a:solidFill>
+                  <a:srgbClr val="FFFFFF"/>
+                </a:solidFill>
+                <a:latin typeface="Apple SD Gothic Neo" pitchFamily="34" charset="0"/>
+                <a:ea typeface="Apple SD Gothic Neo" pitchFamily="34" charset="-122"/>
+                <a:cs typeface="Apple SD Gothic Neo" pitchFamily="34" charset="-120"/>
+              </a:rPr>
+              <a:t>02</a:t>
+            </a:r>
+            <a:endParaRPr lang="en-US" sz="820" dirty="0"/>
+          </a:p>
+        </p:txBody>
+      </p:sp>
+      <p:sp>
+        <p:nvSpPr>
+          <p:cNvPr id="26" name="Text 24"/>
+          <p:cNvSpPr/>
+          <p:nvPr/>
+        </p:nvSpPr>
+        <p:spPr>
+          <a:xfrm>
+            <a:off x="2523744" y="2788920"/>
+            <a:ext cx="1389888" cy="256032"/>
+          </a:xfrm>
+          <a:prstGeom prst="rect">
+            <a:avLst/>
+          </a:prstGeom>
+          <a:noFill/>
+          <a:ln/>
+        </p:spPr>
+        <p:txBody>
+          <a:bodyPr wrap="square" lIns="0" tIns="0" rIns="0" bIns="0" rtlCol="0" anchor="ctr">
+            <a:normAutofit/>
+          </a:bodyPr>
+          <a:lstStyle/>
+          <a:p>
+            <a:pPr indent="0" marL="0">
+              <a:buNone/>
+            </a:pPr>
+            <a:r>
+              <a:rPr lang="en-US" sz="1530" b="1" dirty="0">
+                <a:solidFill>
+                  <a:srgbClr val="14273A"/>
+                </a:solidFill>
+                <a:latin typeface="Apple SD Gothic Neo" pitchFamily="34" charset="0"/>
+                <a:ea typeface="Apple SD Gothic Neo" pitchFamily="34" charset="-122"/>
+                <a:cs typeface="Apple SD Gothic Neo" pitchFamily="34" charset="-120"/>
+              </a:rPr>
+              <a:t>D·TDREPORT</a:t>
+            </a:r>
+            <a:endParaRPr lang="en-US" sz="1530" dirty="0"/>
+          </a:p>
+        </p:txBody>
+      </p:sp>
+      <p:sp>
+        <p:nvSpPr>
+          <p:cNvPr id="27" name="Text 25"/>
+          <p:cNvSpPr/>
+          <p:nvPr/>
+        </p:nvSpPr>
+        <p:spPr>
+          <a:xfrm>
+            <a:off x="2523744" y="3182112"/>
+            <a:ext cx="1389888" cy="1426464"/>
+          </a:xfrm>
+          <a:prstGeom prst="rect">
+            <a:avLst/>
+          </a:prstGeom>
+          <a:noFill/>
+          <a:ln/>
+        </p:spPr>
+        <p:txBody>
+          <a:bodyPr wrap="square" lIns="0" tIns="0" rIns="0" bIns="0" rtlCol="0" anchor="ctr">
+            <a:normAutofit/>
+          </a:bodyPr>
+          <a:lstStyle/>
+          <a:p>
+            <a:pPr indent="0" marL="0">
+              <a:buNone/>
+            </a:pPr>
+            <a:r>
+              <a:rPr lang="en-US" sz="1230" dirty="0">
+                <a:solidFill>
+                  <a:srgbClr val="14273A"/>
+                </a:solidFill>
+                <a:latin typeface="Apple SD Gothic Neo" pitchFamily="34" charset="0"/>
+                <a:ea typeface="Apple SD Gothic Neo" pitchFamily="34" charset="-122"/>
+                <a:cs typeface="Apple SD Gothic Neo" pitchFamily="34" charset="-120"/>
+              </a:rPr>
+              <a:t>TD가 D를</a:t>
+            </a:r>
+            <a:endParaRPr lang="en-US" sz="1230" dirty="0"/>
+          </a:p>
+          <a:p>
+            <a:pPr indent="0" marL="0">
+              <a:buNone/>
+            </a:pPr>
+            <a:r>
+              <a:rPr lang="en-US" sz="1230" dirty="0">
+                <a:solidFill>
+                  <a:srgbClr val="14273A"/>
+                </a:solidFill>
+                <a:latin typeface="Apple SD Gothic Neo" pitchFamily="34" charset="0"/>
+                <a:ea typeface="Apple SD Gothic Neo" pitchFamily="34" charset="-122"/>
+                <a:cs typeface="Apple SD Gothic Neo" pitchFamily="34" charset="-120"/>
+              </a:rPr>
+              <a:t>REPORTDATA에 묶음</a:t>
+            </a:r>
+            <a:endParaRPr lang="en-US" sz="1230" dirty="0"/>
+          </a:p>
+        </p:txBody>
+      </p:sp>
+      <p:sp>
+        <p:nvSpPr>
+          <p:cNvPr id="28" name="Shape 26"/>
+          <p:cNvSpPr/>
+          <p:nvPr/>
+        </p:nvSpPr>
+        <p:spPr>
+          <a:xfrm>
+            <a:off x="4123944" y="3337560"/>
+            <a:ext cx="137160" cy="0"/>
+          </a:xfrm>
+          <a:prstGeom prst="line">
+            <a:avLst/>
+          </a:prstGeom>
+          <a:noFill/>
+          <a:ln w="19050">
+            <a:solidFill>
+              <a:srgbClr val="7044C8"/>
+            </a:solidFill>
+            <a:prstDash val="solid"/>
+            <a:headEnd type="none"/>
+            <a:tailEnd type="triangle"/>
+          </a:ln>
+        </p:spPr>
+      </p:sp>
+      <p:sp>
+        <p:nvSpPr>
+          <p:cNvPr id="29" name="Shape 27"/>
+          <p:cNvSpPr/>
+          <p:nvPr/>
+        </p:nvSpPr>
+        <p:spPr>
+          <a:xfrm>
+            <a:off x="4297680" y="2212848"/>
+            <a:ext cx="1755648" cy="2514600"/>
+          </a:xfrm>
+          <a:prstGeom prst="roundRect">
+            <a:avLst/>
+          </a:prstGeom>
+          <a:solidFill>
+            <a:srgbClr val="FFFFFF"/>
+          </a:solidFill>
+          <a:ln w="8890">
+            <a:solidFill>
+              <a:srgbClr val="FFFFFF"/>
+            </a:solidFill>
+            <a:prstDash val="solid"/>
+          </a:ln>
+        </p:spPr>
+      </p:sp>
+      <p:sp>
+        <p:nvSpPr>
+          <p:cNvPr id="30" name="Shape 28"/>
+          <p:cNvSpPr/>
+          <p:nvPr/>
+        </p:nvSpPr>
+        <p:spPr>
+          <a:xfrm>
+            <a:off x="4462272" y="2377440"/>
             <a:ext cx="1152144" cy="256032"/>
           </a:xfrm>
           <a:prstGeom prst="roundRect">
@@ -2512,13 +3238,13 @@
       </p:sp>
       <p:sp>
         <p:nvSpPr>
-          <p:cNvPr id="13" name="Text 11"/>
-          <p:cNvSpPr/>
-          <p:nvPr/>
-        </p:nvSpPr>
-        <p:spPr>
-          <a:xfrm>
-            <a:off x="3584448" y="1833372"/>
+          <p:cNvPr id="31" name="Text 29"/>
+          <p:cNvSpPr/>
+          <p:nvPr/>
+        </p:nvSpPr>
+        <p:spPr>
+          <a:xfrm>
+            <a:off x="4462272" y="2446020"/>
             <a:ext cx="1152144" cy="91440"/>
           </a:xfrm>
           <a:prstGeom prst="rect">
@@ -2545,7 +3271,7 @@
                 <a:ea typeface="Apple SD Gothic Neo" pitchFamily="34" charset="-122"/>
                 <a:cs typeface="Apple SD Gothic Neo" pitchFamily="34" charset="-120"/>
               </a:rPr>
-              <a:t>02</a:t>
+              <a:t>03</a:t>
             </a:r>
             <a:endParaRPr lang="en-US" sz="820" dirty="0"/>
           </a:p>
@@ -2553,14 +3279,14 @@
       </p:sp>
       <p:sp>
         <p:nvSpPr>
-          <p:cNvPr id="14" name="Text 12"/>
-          <p:cNvSpPr/>
-          <p:nvPr/>
-        </p:nvSpPr>
-        <p:spPr>
-          <a:xfrm>
-            <a:off x="3602736" y="2176272"/>
-            <a:ext cx="2121408" cy="256032"/>
+          <p:cNvPr id="32" name="Text 30"/>
+          <p:cNvSpPr/>
+          <p:nvPr/>
+        </p:nvSpPr>
+        <p:spPr>
+          <a:xfrm>
+            <a:off x="4480560" y="2788920"/>
+            <a:ext cx="1389888" cy="256032"/>
           </a:xfrm>
           <a:prstGeom prst="rect">
             <a:avLst/>
@@ -2586,7 +3312,7 @@
                 <a:ea typeface="Apple SD Gothic Neo" pitchFamily="34" charset="-122"/>
                 <a:cs typeface="Apple SD Gothic Neo" pitchFamily="34" charset="-120"/>
               </a:rPr>
-              <a:t>Quote를 만든다</a:t>
+              <a:t>TDQE Quote</a:t>
             </a:r>
             <a:endParaRPr lang="en-US" sz="1530" dirty="0"/>
           </a:p>
@@ -2594,14 +3320,14 @@
       </p:sp>
       <p:sp>
         <p:nvSpPr>
-          <p:cNvPr id="15" name="Text 13"/>
-          <p:cNvSpPr/>
-          <p:nvPr/>
-        </p:nvSpPr>
-        <p:spPr>
-          <a:xfrm>
-            <a:off x="3602736" y="2569464"/>
-            <a:ext cx="2121408" cy="2340864"/>
+          <p:cNvPr id="33" name="Text 31"/>
+          <p:cNvSpPr/>
+          <p:nvPr/>
+        </p:nvSpPr>
+        <p:spPr>
+          <a:xfrm>
+            <a:off x="4480560" y="3182112"/>
+            <a:ext cx="1389888" cy="1426464"/>
           </a:xfrm>
           <a:prstGeom prst="rect">
             <a:avLst/>
@@ -2627,28 +3353,45 @@
                 <a:ea typeface="Apple SD Gothic Neo" pitchFamily="34" charset="-122"/>
                 <a:cs typeface="Apple SD Gothic Neo" pitchFamily="34" charset="-120"/>
               </a:rPr>
-              <a:t>TD가 D를 REPORTDATA에 넣고, QGS가 TDREPORT를 TDQE로 운반해 signed Quote를 받는다.</a:t>
+              <a:t>QGS transport</a:t>
             </a:r>
             <a:endParaRPr lang="en-US" sz="1230" dirty="0"/>
           </a:p>
-        </p:txBody>
-      </p:sp>
-      <p:sp>
-        <p:nvSpPr>
-          <p:cNvPr id="16" name="Shape 14"/>
-          <p:cNvSpPr/>
-          <p:nvPr/>
-        </p:nvSpPr>
-        <p:spPr>
-          <a:xfrm>
-            <a:off x="5943600" y="3246120"/>
-            <a:ext cx="310896" cy="0"/>
+          <a:p>
+            <a:pPr indent="0" marL="0">
+              <a:buNone/>
+            </a:pPr>
+            <a:r>
+              <a:rPr lang="en-US" sz="1230" dirty="0">
+                <a:solidFill>
+                  <a:srgbClr val="14273A"/>
+                </a:solidFill>
+                <a:latin typeface="Apple SD Gothic Neo" pitchFamily="34" charset="0"/>
+                <a:ea typeface="Apple SD Gothic Neo" pitchFamily="34" charset="-122"/>
+                <a:cs typeface="Apple SD Gothic Neo" pitchFamily="34" charset="-120"/>
+              </a:rPr>
+              <a:t>TDQE가 서명</a:t>
+            </a:r>
+            <a:endParaRPr lang="en-US" sz="1230" dirty="0"/>
+          </a:p>
+        </p:txBody>
+      </p:sp>
+      <p:sp>
+        <p:nvSpPr>
+          <p:cNvPr id="34" name="Shape 32"/>
+          <p:cNvSpPr/>
+          <p:nvPr/>
+        </p:nvSpPr>
+        <p:spPr>
+          <a:xfrm>
+            <a:off x="6080760" y="3337560"/>
+            <a:ext cx="137160" cy="0"/>
           </a:xfrm>
           <a:prstGeom prst="line">
             <a:avLst/>
           </a:prstGeom>
           <a:noFill/>
-          <a:ln w="22860">
+          <a:ln w="19050">
             <a:solidFill>
               <a:srgbClr val="0B7890"/>
             </a:solidFill>
@@ -2660,14 +3403,14 @@
       </p:sp>
       <p:sp>
         <p:nvSpPr>
-          <p:cNvPr id="17" name="Shape 15"/>
-          <p:cNvSpPr/>
-          <p:nvPr/>
-        </p:nvSpPr>
-        <p:spPr>
-          <a:xfrm>
-            <a:off x="6309360" y="1600200"/>
-            <a:ext cx="2487168" cy="3429000"/>
+          <p:cNvPr id="35" name="Shape 33"/>
+          <p:cNvSpPr/>
+          <p:nvPr/>
+        </p:nvSpPr>
+        <p:spPr>
+          <a:xfrm>
+            <a:off x="6254496" y="2212848"/>
+            <a:ext cx="1755648" cy="2514600"/>
           </a:xfrm>
           <a:prstGeom prst="roundRect">
             <a:avLst/>
@@ -2685,13 +3428,228 @@
       </p:sp>
       <p:sp>
         <p:nvSpPr>
-          <p:cNvPr id="18" name="Shape 16"/>
-          <p:cNvSpPr/>
-          <p:nvPr/>
-        </p:nvSpPr>
-        <p:spPr>
-          <a:xfrm>
-            <a:off x="6473952" y="1764792"/>
+          <p:cNvPr id="36" name="Shape 34"/>
+          <p:cNvSpPr/>
+          <p:nvPr/>
+        </p:nvSpPr>
+        <p:spPr>
+          <a:xfrm>
+            <a:off x="6419088" y="2377440"/>
+            <a:ext cx="1152144" cy="256032"/>
+          </a:xfrm>
+          <a:prstGeom prst="roundRect">
+            <a:avLst/>
+          </a:prstGeom>
+          <a:solidFill>
+            <a:srgbClr val="9A6500"/>
+          </a:solidFill>
+          <a:ln w="8890">
+            <a:solidFill>
+              <a:srgbClr val="9A6500"/>
+            </a:solidFill>
+            <a:prstDash val="solid"/>
+          </a:ln>
+        </p:spPr>
+      </p:sp>
+      <p:sp>
+        <p:nvSpPr>
+          <p:cNvPr id="37" name="Text 35"/>
+          <p:cNvSpPr/>
+          <p:nvPr/>
+        </p:nvSpPr>
+        <p:spPr>
+          <a:xfrm>
+            <a:off x="6419088" y="2446020"/>
+            <a:ext cx="1152144" cy="91440"/>
+          </a:xfrm>
+          <a:prstGeom prst="rect">
+            <a:avLst/>
+          </a:prstGeom>
+          <a:noFill/>
+          <a:ln/>
+        </p:spPr>
+        <p:txBody>
+          <a:bodyPr wrap="square" lIns="0" tIns="0" rIns="0" bIns="0" rtlCol="0" anchor="ctr">
+            <a:normAutofit/>
+          </a:bodyPr>
+          <a:lstStyle/>
+          <a:p>
+            <a:pPr algn="ctr" indent="0" marL="0">
+              <a:buNone/>
+            </a:pPr>
+            <a:r>
+              <a:rPr lang="en-US" sz="820" b="1" dirty="0">
+                <a:solidFill>
+                  <a:srgbClr val="FFFFFF"/>
+                </a:solidFill>
+                <a:latin typeface="Apple SD Gothic Neo" pitchFamily="34" charset="0"/>
+                <a:ea typeface="Apple SD Gothic Neo" pitchFamily="34" charset="-122"/>
+                <a:cs typeface="Apple SD Gothic Neo" pitchFamily="34" charset="-120"/>
+              </a:rPr>
+              <a:t>04</a:t>
+            </a:r>
+            <a:endParaRPr lang="en-US" sz="820" dirty="0"/>
+          </a:p>
+        </p:txBody>
+      </p:sp>
+      <p:sp>
+        <p:nvSpPr>
+          <p:cNvPr id="38" name="Text 36"/>
+          <p:cNvSpPr/>
+          <p:nvPr/>
+        </p:nvSpPr>
+        <p:spPr>
+          <a:xfrm>
+            <a:off x="6437376" y="2788920"/>
+            <a:ext cx="1389888" cy="256032"/>
+          </a:xfrm>
+          <a:prstGeom prst="rect">
+            <a:avLst/>
+          </a:prstGeom>
+          <a:noFill/>
+          <a:ln/>
+        </p:spPr>
+        <p:txBody>
+          <a:bodyPr wrap="square" lIns="0" tIns="0" rIns="0" bIns="0" rtlCol="0" anchor="ctr">
+            <a:normAutofit/>
+          </a:bodyPr>
+          <a:lstStyle/>
+          <a:p>
+            <a:pPr indent="0" marL="0">
+              <a:buNone/>
+            </a:pPr>
+            <a:r>
+              <a:rPr lang="en-US" sz="1530" b="1" dirty="0">
+                <a:solidFill>
+                  <a:srgbClr val="14273A"/>
+                </a:solidFill>
+                <a:latin typeface="Apple SD Gothic Neo" pitchFamily="34" charset="0"/>
+                <a:ea typeface="Apple SD Gothic Neo" pitchFamily="34" charset="-122"/>
+                <a:cs typeface="Apple SD Gothic Neo" pitchFamily="34" charset="-120"/>
+              </a:rPr>
+              <a:t>K/D/E 평가</a:t>
+            </a:r>
+            <a:endParaRPr lang="en-US" sz="1530" dirty="0"/>
+          </a:p>
+        </p:txBody>
+      </p:sp>
+      <p:sp>
+        <p:nvSpPr>
+          <p:cNvPr id="39" name="Text 37"/>
+          <p:cNvSpPr/>
+          <p:nvPr/>
+        </p:nvSpPr>
+        <p:spPr>
+          <a:xfrm>
+            <a:off x="6437376" y="3182112"/>
+            <a:ext cx="1389888" cy="1426464"/>
+          </a:xfrm>
+          <a:prstGeom prst="rect">
+            <a:avLst/>
+          </a:prstGeom>
+          <a:noFill/>
+          <a:ln/>
+        </p:spPr>
+        <p:txBody>
+          <a:bodyPr wrap="square" lIns="0" tIns="0" rIns="0" bIns="0" rtlCol="0" anchor="ctr">
+            <a:normAutofit/>
+          </a:bodyPr>
+          <a:lstStyle/>
+          <a:p>
+            <a:pPr indent="0" marL="0">
+              <a:buNone/>
+            </a:pPr>
+            <a:r>
+              <a:rPr lang="en-US" sz="1230" dirty="0">
+                <a:solidFill>
+                  <a:srgbClr val="14273A"/>
+                </a:solidFill>
+                <a:latin typeface="Apple SD Gothic Neo" pitchFamily="34" charset="0"/>
+                <a:ea typeface="Apple SD Gothic Neo" pitchFamily="34" charset="-122"/>
+                <a:cs typeface="Apple SD Gothic Neo" pitchFamily="34" charset="-120"/>
+              </a:rPr>
+              <a:t>RP/KMS→Verifier</a:t>
+            </a:r>
+            <a:endParaRPr lang="en-US" sz="1230" dirty="0"/>
+          </a:p>
+          <a:p>
+            <a:pPr indent="0" marL="0">
+              <a:buNone/>
+            </a:pPr>
+            <a:r>
+              <a:rPr lang="en-US" sz="1230" dirty="0">
+                <a:solidFill>
+                  <a:srgbClr val="14273A"/>
+                </a:solidFill>
+                <a:latin typeface="Apple SD Gothic Neo" pitchFamily="34" charset="0"/>
+                <a:ea typeface="Apple SD Gothic Neo" pitchFamily="34" charset="-122"/>
+                <a:cs typeface="Apple SD Gothic Neo" pitchFamily="34" charset="-120"/>
+              </a:rPr>
+              <a:t>Evidence appraisal</a:t>
+            </a:r>
+            <a:endParaRPr lang="en-US" sz="1230" dirty="0"/>
+          </a:p>
+        </p:txBody>
+      </p:sp>
+      <p:sp>
+        <p:nvSpPr>
+          <p:cNvPr id="40" name="Shape 38"/>
+          <p:cNvSpPr/>
+          <p:nvPr/>
+        </p:nvSpPr>
+        <p:spPr>
+          <a:xfrm>
+            <a:off x="8037576" y="3337560"/>
+            <a:ext cx="137160" cy="0"/>
+          </a:xfrm>
+          <a:prstGeom prst="line">
+            <a:avLst/>
+          </a:prstGeom>
+          <a:noFill/>
+          <a:ln w="19050">
+            <a:solidFill>
+              <a:srgbClr val="9A6500"/>
+            </a:solidFill>
+            <a:prstDash val="solid"/>
+            <a:headEnd type="none"/>
+            <a:tailEnd type="triangle"/>
+          </a:ln>
+        </p:spPr>
+      </p:sp>
+      <p:sp>
+        <p:nvSpPr>
+          <p:cNvPr id="41" name="Shape 39"/>
+          <p:cNvSpPr/>
+          <p:nvPr/>
+        </p:nvSpPr>
+        <p:spPr>
+          <a:xfrm>
+            <a:off x="8211312" y="2212848"/>
+            <a:ext cx="1755648" cy="2514600"/>
+          </a:xfrm>
+          <a:prstGeom prst="roundRect">
+            <a:avLst/>
+          </a:prstGeom>
+          <a:solidFill>
+            <a:srgbClr val="FFFFFF"/>
+          </a:solidFill>
+          <a:ln w="8890">
+            <a:solidFill>
+              <a:srgbClr val="FFFFFF"/>
+            </a:solidFill>
+            <a:prstDash val="solid"/>
+          </a:ln>
+        </p:spPr>
+      </p:sp>
+      <p:sp>
+        <p:nvSpPr>
+          <p:cNvPr id="42" name="Shape 40"/>
+          <p:cNvSpPr/>
+          <p:nvPr/>
+        </p:nvSpPr>
+        <p:spPr>
+          <a:xfrm>
+            <a:off x="8375904" y="2377440"/>
             <a:ext cx="1152144" cy="256032"/>
           </a:xfrm>
           <a:prstGeom prst="roundRect">
@@ -2710,13 +3668,13 @@
       </p:sp>
       <p:sp>
         <p:nvSpPr>
-          <p:cNvPr id="19" name="Text 17"/>
-          <p:cNvSpPr/>
-          <p:nvPr/>
-        </p:nvSpPr>
-        <p:spPr>
-          <a:xfrm>
-            <a:off x="6473952" y="1833372"/>
+          <p:cNvPr id="43" name="Text 41"/>
+          <p:cNvSpPr/>
+          <p:nvPr/>
+        </p:nvSpPr>
+        <p:spPr>
+          <a:xfrm>
+            <a:off x="8375904" y="2446020"/>
             <a:ext cx="1152144" cy="91440"/>
           </a:xfrm>
           <a:prstGeom prst="rect">
@@ -2743,7 +3701,7 @@
                 <a:ea typeface="Apple SD Gothic Neo" pitchFamily="34" charset="-122"/>
                 <a:cs typeface="Apple SD Gothic Neo" pitchFamily="34" charset="-120"/>
               </a:rPr>
-              <a:t>03</a:t>
+              <a:t>05</a:t>
             </a:r>
             <a:endParaRPr lang="en-US" sz="820" dirty="0"/>
           </a:p>
@@ -2751,14 +3709,14 @@
       </p:sp>
       <p:sp>
         <p:nvSpPr>
-          <p:cNvPr id="20" name="Text 18"/>
-          <p:cNvSpPr/>
-          <p:nvPr/>
-        </p:nvSpPr>
-        <p:spPr>
-          <a:xfrm>
-            <a:off x="6492240" y="2176272"/>
-            <a:ext cx="2121408" cy="256032"/>
+          <p:cNvPr id="44" name="Text 42"/>
+          <p:cNvSpPr/>
+          <p:nvPr/>
+        </p:nvSpPr>
+        <p:spPr>
+          <a:xfrm>
+            <a:off x="8394192" y="2788920"/>
+            <a:ext cx="1389888" cy="256032"/>
           </a:xfrm>
           <a:prstGeom prst="rect">
             <a:avLst/>
@@ -2784,7 +3742,7 @@
                 <a:ea typeface="Apple SD Gothic Neo" pitchFamily="34" charset="-122"/>
                 <a:cs typeface="Apple SD Gothic Neo" pitchFamily="34" charset="-120"/>
               </a:rPr>
-              <a:t>Evidence를 평가한다</a:t>
+              <a:t>signed Result</a:t>
             </a:r>
             <a:endParaRPr lang="en-US" sz="1530" dirty="0"/>
           </a:p>
@@ -2792,14 +3750,14 @@
       </p:sp>
       <p:sp>
         <p:nvSpPr>
-          <p:cNvPr id="21" name="Text 19"/>
-          <p:cNvSpPr/>
-          <p:nvPr/>
-        </p:nvSpPr>
-        <p:spPr>
-          <a:xfrm>
-            <a:off x="6492240" y="2569464"/>
-            <a:ext cx="2121408" cy="2340864"/>
+          <p:cNvPr id="45" name="Text 43"/>
+          <p:cNvSpPr/>
+          <p:nvPr/>
+        </p:nvSpPr>
+        <p:spPr>
+          <a:xfrm>
+            <a:off x="8394192" y="3182112"/>
+            <a:ext cx="1389888" cy="1426464"/>
           </a:xfrm>
           <a:prstGeom prst="rect">
             <a:avLst/>
@@ -2825,28 +3783,45 @@
                 <a:ea typeface="Apple SD Gothic Neo" pitchFamily="34" charset="-122"/>
                 <a:cs typeface="Apple SD Gothic Neo" pitchFamily="34" charset="-120"/>
               </a:rPr>
-              <a:t>RP/KMS가 Quote·key·동일 문맥을 Verifier에 보내면, Verifier가 K/D/E와 collateral을 확인한다.</a:t>
+              <a:t>verdict·E·K를</a:t>
             </a:r>
             <a:endParaRPr lang="en-US" sz="1230" dirty="0"/>
           </a:p>
-        </p:txBody>
-      </p:sp>
-      <p:sp>
-        <p:nvSpPr>
-          <p:cNvPr id="22" name="Shape 20"/>
-          <p:cNvSpPr/>
-          <p:nvPr/>
-        </p:nvSpPr>
-        <p:spPr>
-          <a:xfrm>
-            <a:off x="8833104" y="3246120"/>
-            <a:ext cx="310896" cy="0"/>
+          <a:p>
+            <a:pPr indent="0" marL="0">
+              <a:buNone/>
+            </a:pPr>
+            <a:r>
+              <a:rPr lang="en-US" sz="1230" dirty="0">
+                <a:solidFill>
+                  <a:srgbClr val="14273A"/>
+                </a:solidFill>
+                <a:latin typeface="Apple SD Gothic Neo" pitchFamily="34" charset="0"/>
+                <a:ea typeface="Apple SD Gothic Neo" pitchFamily="34" charset="-122"/>
+                <a:cs typeface="Apple SD Gothic Neo" pitchFamily="34" charset="-120"/>
+              </a:rPr>
+              <a:t>Verifier가 서명</a:t>
+            </a:r>
+            <a:endParaRPr lang="en-US" sz="1230" dirty="0"/>
+          </a:p>
+        </p:txBody>
+      </p:sp>
+      <p:sp>
+        <p:nvSpPr>
+          <p:cNvPr id="46" name="Shape 44"/>
+          <p:cNvSpPr/>
+          <p:nvPr/>
+        </p:nvSpPr>
+        <p:spPr>
+          <a:xfrm>
+            <a:off x="9994392" y="3337560"/>
+            <a:ext cx="137160" cy="0"/>
           </a:xfrm>
           <a:prstGeom prst="line">
             <a:avLst/>
           </a:prstGeom>
           <a:noFill/>
-          <a:ln w="22860">
+          <a:ln w="19050">
             <a:solidFill>
               <a:srgbClr val="7044C8"/>
             </a:solidFill>
@@ -2858,14 +3833,14 @@
       </p:sp>
       <p:sp>
         <p:nvSpPr>
-          <p:cNvPr id="23" name="Shape 21"/>
-          <p:cNvSpPr/>
-          <p:nvPr/>
-        </p:nvSpPr>
-        <p:spPr>
-          <a:xfrm>
-            <a:off x="9198864" y="1600200"/>
-            <a:ext cx="2487168" cy="3429000"/>
+          <p:cNvPr id="47" name="Shape 45"/>
+          <p:cNvSpPr/>
+          <p:nvPr/>
+        </p:nvSpPr>
+        <p:spPr>
+          <a:xfrm>
+            <a:off x="10168128" y="2212848"/>
+            <a:ext cx="1755648" cy="2514600"/>
           </a:xfrm>
           <a:prstGeom prst="roundRect">
             <a:avLst/>
@@ -2883,13 +3858,13 @@
       </p:sp>
       <p:sp>
         <p:nvSpPr>
-          <p:cNvPr id="24" name="Shape 22"/>
-          <p:cNvSpPr/>
-          <p:nvPr/>
-        </p:nvSpPr>
-        <p:spPr>
-          <a:xfrm>
-            <a:off x="9363456" y="1764792"/>
+          <p:cNvPr id="48" name="Shape 46"/>
+          <p:cNvSpPr/>
+          <p:nvPr/>
+        </p:nvSpPr>
+        <p:spPr>
+          <a:xfrm>
+            <a:off x="10332720" y="2377440"/>
             <a:ext cx="1152144" cy="256032"/>
           </a:xfrm>
           <a:prstGeom prst="roundRect">
@@ -2908,13 +3883,13 @@
       </p:sp>
       <p:sp>
         <p:nvSpPr>
-          <p:cNvPr id="25" name="Text 23"/>
-          <p:cNvSpPr/>
-          <p:nvPr/>
-        </p:nvSpPr>
-        <p:spPr>
-          <a:xfrm>
-            <a:off x="9363456" y="1833372"/>
+          <p:cNvPr id="49" name="Text 47"/>
+          <p:cNvSpPr/>
+          <p:nvPr/>
+        </p:nvSpPr>
+        <p:spPr>
+          <a:xfrm>
+            <a:off x="10332720" y="2446020"/>
             <a:ext cx="1152144" cy="91440"/>
           </a:xfrm>
           <a:prstGeom prst="rect">
@@ -2941,7 +3916,7 @@
                 <a:ea typeface="Apple SD Gothic Neo" pitchFamily="34" charset="-122"/>
                 <a:cs typeface="Apple SD Gothic Neo" pitchFamily="34" charset="-120"/>
               </a:rPr>
-              <a:t>04</a:t>
+              <a:t>06</a:t>
             </a:r>
             <a:endParaRPr lang="en-US" sz="820" dirty="0"/>
           </a:p>
@@ -2949,14 +3924,14 @@
       </p:sp>
       <p:sp>
         <p:nvSpPr>
-          <p:cNvPr id="26" name="Text 24"/>
-          <p:cNvSpPr/>
-          <p:nvPr/>
-        </p:nvSpPr>
-        <p:spPr>
-          <a:xfrm>
-            <a:off x="9381744" y="2176272"/>
-            <a:ext cx="2121408" cy="256032"/>
+          <p:cNvPr id="50" name="Text 48"/>
+          <p:cNvSpPr/>
+          <p:nvPr/>
+        </p:nvSpPr>
+        <p:spPr>
+          <a:xfrm>
+            <a:off x="10351008" y="2788920"/>
+            <a:ext cx="1389888" cy="256032"/>
           </a:xfrm>
           <a:prstGeom prst="rect">
             <a:avLst/>
@@ -2982,7 +3957,7 @@
                 <a:ea typeface="Apple SD Gothic Neo" pitchFamily="34" charset="-122"/>
                 <a:cs typeface="Apple SD Gothic Neo" pitchFamily="34" charset="-120"/>
               </a:rPr>
-              <a:t>Result를 사용한다</a:t>
+              <a:t>PoP → 공개</a:t>
             </a:r>
             <a:endParaRPr lang="en-US" sz="1530" dirty="0"/>
           </a:p>
@@ -2990,14 +3965,14 @@
       </p:sp>
       <p:sp>
         <p:nvSpPr>
-          <p:cNvPr id="27" name="Text 25"/>
-          <p:cNvSpPr/>
-          <p:nvPr/>
-        </p:nvSpPr>
-        <p:spPr>
-          <a:xfrm>
-            <a:off x="9381744" y="2569464"/>
-            <a:ext cx="2121408" cy="2340864"/>
+          <p:cNvPr id="51" name="Text 49"/>
+          <p:cNvSpPr/>
+          <p:nvPr/>
+        </p:nvSpPr>
+        <p:spPr>
+          <a:xfrm>
+            <a:off x="10351008" y="3182112"/>
+            <a:ext cx="1389888" cy="1426464"/>
           </a:xfrm>
           <a:prstGeom prst="rect">
             <a:avLst/>
@@ -3023,22 +3998,171 @@
                 <a:ea typeface="Apple SD Gothic Neo" pitchFamily="34" charset="-122"/>
                 <a:cs typeface="Apple SD Gothic Neo" pitchFamily="34" charset="-120"/>
               </a:rPr>
-              <a:t>RP/KMS가 signed Result·time·E/K·PoP를 확인한 뒤 allow일 때만 secret을 보낸다.</a:t>
+              <a:t>키 소유 증명 뒤</a:t>
             </a:r>
             <a:endParaRPr lang="en-US" sz="1230" dirty="0"/>
           </a:p>
-        </p:txBody>
-      </p:sp>
-      <p:sp>
-        <p:nvSpPr>
-          <p:cNvPr id="28" name="Shape 26"/>
-          <p:cNvSpPr/>
-          <p:nvPr/>
-        </p:nvSpPr>
-        <p:spPr>
-          <a:xfrm>
-            <a:off x="658368" y="5413248"/>
-            <a:ext cx="10835640" cy="566928"/>
+          <a:p>
+            <a:pPr indent="0" marL="0">
+              <a:buNone/>
+            </a:pPr>
+            <a:r>
+              <a:rPr lang="en-US" sz="1230" dirty="0">
+                <a:solidFill>
+                  <a:srgbClr val="14273A"/>
+                </a:solidFill>
+                <a:latin typeface="Apple SD Gothic Neo" pitchFamily="34" charset="0"/>
+                <a:ea typeface="Apple SD Gothic Neo" pitchFamily="34" charset="-122"/>
+                <a:cs typeface="Apple SD Gothic Neo" pitchFamily="34" charset="-120"/>
+              </a:rPr>
+              <a:t>same-K secret</a:t>
+            </a:r>
+            <a:endParaRPr lang="en-US" sz="1230" dirty="0"/>
+          </a:p>
+        </p:txBody>
+      </p:sp>
+      <p:sp>
+        <p:nvSpPr>
+          <p:cNvPr id="52" name="Shape 50"/>
+          <p:cNvSpPr/>
+          <p:nvPr/>
+        </p:nvSpPr>
+        <p:spPr>
+          <a:xfrm>
+            <a:off x="658368" y="5010912"/>
+            <a:ext cx="10835640" cy="438912"/>
+          </a:xfrm>
+          <a:prstGeom prst="roundRect">
+            <a:avLst/>
+          </a:prstGeom>
+          <a:solidFill>
+            <a:srgbClr val="EAF7EF"/>
+          </a:solidFill>
+          <a:ln w="8890">
+            <a:solidFill>
+              <a:srgbClr val="EAF7EF"/>
+            </a:solidFill>
+            <a:prstDash val="solid"/>
+          </a:ln>
+        </p:spPr>
+      </p:sp>
+      <p:sp>
+        <p:nvSpPr>
+          <p:cNvPr id="53" name="Shape 51"/>
+          <p:cNvSpPr/>
+          <p:nvPr/>
+        </p:nvSpPr>
+        <p:spPr>
+          <a:xfrm>
+            <a:off x="822960" y="5175504"/>
+            <a:ext cx="822960" cy="256032"/>
+          </a:xfrm>
+          <a:prstGeom prst="roundRect">
+            <a:avLst/>
+          </a:prstGeom>
+          <a:solidFill>
+            <a:srgbClr val="14804A"/>
+          </a:solidFill>
+          <a:ln w="8890">
+            <a:solidFill>
+              <a:srgbClr val="14804A"/>
+            </a:solidFill>
+            <a:prstDash val="solid"/>
+          </a:ln>
+        </p:spPr>
+      </p:sp>
+      <p:sp>
+        <p:nvSpPr>
+          <p:cNvPr id="54" name="Text 52"/>
+          <p:cNvSpPr/>
+          <p:nvPr/>
+        </p:nvSpPr>
+        <p:spPr>
+          <a:xfrm>
+            <a:off x="822960" y="5244084"/>
+            <a:ext cx="822960" cy="91440"/>
+          </a:xfrm>
+          <a:prstGeom prst="rect">
+            <a:avLst/>
+          </a:prstGeom>
+          <a:noFill/>
+          <a:ln/>
+        </p:spPr>
+        <p:txBody>
+          <a:bodyPr wrap="square" lIns="0" tIns="0" rIns="0" bIns="0" rtlCol="0" anchor="ctr">
+            <a:normAutofit/>
+          </a:bodyPr>
+          <a:lstStyle/>
+          <a:p>
+            <a:pPr algn="ctr" indent="0" marL="0">
+              <a:buNone/>
+            </a:pPr>
+            <a:r>
+              <a:rPr lang="en-US" sz="820" b="1" dirty="0">
+                <a:solidFill>
+                  <a:srgbClr val="FFFFFF"/>
+                </a:solidFill>
+                <a:latin typeface="Apple SD Gothic Neo" pitchFamily="34" charset="0"/>
+                <a:ea typeface="Apple SD Gothic Neo" pitchFamily="34" charset="-122"/>
+                <a:cs typeface="Apple SD Gothic Neo" pitchFamily="34" charset="-120"/>
+              </a:rPr>
+              <a:t>공개 branch</a:t>
+            </a:r>
+            <a:endParaRPr lang="en-US" sz="820" dirty="0"/>
+          </a:p>
+        </p:txBody>
+      </p:sp>
+      <p:sp>
+        <p:nvSpPr>
+          <p:cNvPr id="55" name="Text 53"/>
+          <p:cNvSpPr/>
+          <p:nvPr/>
+        </p:nvSpPr>
+        <p:spPr>
+          <a:xfrm>
+            <a:off x="1828800" y="5175504"/>
+            <a:ext cx="9482328" cy="237744"/>
+          </a:xfrm>
+          <a:prstGeom prst="rect">
+            <a:avLst/>
+          </a:prstGeom>
+          <a:noFill/>
+          <a:ln/>
+        </p:spPr>
+        <p:txBody>
+          <a:bodyPr wrap="square" lIns="0" tIns="0" rIns="0" bIns="0" rtlCol="0" anchor="ctr">
+            <a:normAutofit/>
+          </a:bodyPr>
+          <a:lstStyle/>
+          <a:p>
+            <a:pPr indent="0" marL="0">
+              <a:buNone/>
+            </a:pPr>
+            <a:r>
+              <a:rPr lang="en-US" sz="1330" dirty="0">
+                <a:solidFill>
+                  <a:srgbClr val="14804A"/>
+                </a:solidFill>
+                <a:latin typeface="Apple SD Gothic Neo" pitchFamily="34" charset="0"/>
+                <a:ea typeface="Apple SD Gothic Neo" pitchFamily="34" charset="-122"/>
+                <a:cs typeface="Apple SD Gothic Neo" pitchFamily="34" charset="-120"/>
+              </a:rPr>
+              <a:t>allow + Result/time/E/K + PoP + unused→release_committed 성공 → same approved-K channel → secret</a:t>
+            </a:r>
+            <a:endParaRPr lang="en-US" sz="1330" dirty="0"/>
+          </a:p>
+        </p:txBody>
+      </p:sp>
+      <p:sp>
+        <p:nvSpPr>
+          <p:cNvPr id="56" name="Shape 54"/>
+          <p:cNvSpPr/>
+          <p:nvPr/>
+        </p:nvSpPr>
+        <p:spPr>
+          <a:xfrm>
+            <a:off x="658368" y="5532120"/>
+            <a:ext cx="10835640" cy="438912"/>
           </a:xfrm>
           <a:prstGeom prst="roundRect">
             <a:avLst/>
@@ -3056,13 +4180,13 @@
       </p:sp>
       <p:sp>
         <p:nvSpPr>
-          <p:cNvPr id="29" name="Shape 27"/>
-          <p:cNvSpPr/>
-          <p:nvPr/>
-        </p:nvSpPr>
-        <p:spPr>
-          <a:xfrm>
-            <a:off x="822960" y="5577840"/>
+          <p:cNvPr id="57" name="Shape 55"/>
+          <p:cNvSpPr/>
+          <p:nvPr/>
+        </p:nvSpPr>
+        <p:spPr>
+          <a:xfrm>
+            <a:off x="822960" y="5696712"/>
             <a:ext cx="822960" cy="256032"/>
           </a:xfrm>
           <a:prstGeom prst="roundRect">
@@ -3081,13 +4205,13 @@
       </p:sp>
       <p:sp>
         <p:nvSpPr>
-          <p:cNvPr id="30" name="Text 28"/>
-          <p:cNvSpPr/>
-          <p:nvPr/>
-        </p:nvSpPr>
-        <p:spPr>
-          <a:xfrm>
-            <a:off x="822960" y="5646420"/>
+          <p:cNvPr id="58" name="Text 56"/>
+          <p:cNvSpPr/>
+          <p:nvPr/>
+        </p:nvSpPr>
+        <p:spPr>
+          <a:xfrm>
+            <a:off x="822960" y="5765292"/>
             <a:ext cx="822960" cy="91440"/>
           </a:xfrm>
           <a:prstGeom prst="rect">
@@ -3114,7 +4238,7 @@
                 <a:ea typeface="Apple SD Gothic Neo" pitchFamily="34" charset="-122"/>
                 <a:cs typeface="Apple SD Gothic Neo" pitchFamily="34" charset="-120"/>
               </a:rPr>
-              <a:t>실패 규칙</a:t>
+              <a:t>NO KEY branch</a:t>
             </a:r>
             <a:endParaRPr lang="en-US" sz="820" dirty="0"/>
           </a:p>
@@ -3122,14 +4246,14 @@
       </p:sp>
       <p:sp>
         <p:nvSpPr>
-          <p:cNvPr id="31" name="Text 29"/>
-          <p:cNvSpPr/>
-          <p:nvPr/>
-        </p:nvSpPr>
-        <p:spPr>
-          <a:xfrm>
-            <a:off x="1828800" y="5577840"/>
-            <a:ext cx="9482328" cy="365760"/>
+          <p:cNvPr id="59" name="Text 57"/>
+          <p:cNvSpPr/>
+          <p:nvPr/>
+        </p:nvSpPr>
+        <p:spPr>
+          <a:xfrm>
+            <a:off x="1828800" y="5696712"/>
+            <a:ext cx="9482328" cy="237744"/>
           </a:xfrm>
           <a:prstGeom prst="rect">
             <a:avLst/>
@@ -3155,7 +4279,7 @@
                 <a:ea typeface="Apple SD Gothic Neo" pitchFamily="34" charset="-122"/>
                 <a:cs typeface="Apple SD Gothic Neo" pitchFamily="34" charset="-120"/>
               </a:rPr>
-              <a:t>deny·replay·expiry·invalid collateral·failed PoP 중 하나라도 발생하면 RP/KMS는 NO KEY로 끝낸다. 재시도는 기존 상태를 재사용하지 않고 새 nonce로 시작한다.</a:t>
+              <a:t>deny · expiry · replay · invalid Result/collateral · failed PoP · terminal error → NO KEY. 재시도는 기존 record를 닫고 새 nonce로 시작한다.</a:t>
             </a:r>
             <a:endParaRPr lang="en-US" sz="1330" dirty="0"/>
           </a:p>
@@ -3163,7 +4287,7 @@
       </p:sp>
       <p:sp>
         <p:nvSpPr>
-          <p:cNvPr id="32" name="Shape 30"/>
+          <p:cNvPr id="60" name="Shape 58"/>
           <p:cNvSpPr/>
           <p:nvPr/>
         </p:nvSpPr>
@@ -3186,7 +4310,7 @@
       </p:sp>
       <p:sp>
         <p:nvSpPr>
-          <p:cNvPr id="33" name="Text 31"/>
+          <p:cNvPr id="61" name="Text 59"/>
           <p:cNvSpPr/>
           <p:nvPr/>
         </p:nvSpPr>
@@ -3219,7 +4343,7 @@
                 <a:ea typeface="Apple SD Gothic Neo" pitchFamily="34" charset="-122"/>
                 <a:cs typeface="Apple SD Gothic Neo" pitchFamily="34" charset="-120"/>
               </a:rPr>
-              <a:t>C-003/C-004/C-006 · E-003–E-018 · failure path</a:t>
+              <a:t>C-003/C-004/C-006 · E-003–E-018 · K/D/E/PoP local onboarding · 〔S-002,S-003〕</a:t>
             </a:r>
             <a:endParaRPr lang="en-US" sz="780" dirty="0"/>
           </a:p>
@@ -3227,7 +4351,7 @@
       </p:sp>
       <p:sp>
         <p:nvSpPr>
-          <p:cNvPr id="34" name="Text 32"/>
+          <p:cNvPr id="62" name="Text 60"/>
           <p:cNvSpPr/>
           <p:nvPr/>
         </p:nvSpPr>
@@ -3260,7 +4384,7 @@
                 <a:ea typeface="Apple SD Gothic Neo" pitchFamily="34" charset="-122"/>
                 <a:cs typeface="Apple SD Gothic Neo" pitchFamily="34" charset="-120"/>
               </a:rPr>
-              <a:t>Sources: RFC 9334 · Intel DCAP / TDX documentation</a:t>
+              <a:t>Source markers: 〔S-…〕 · Appendix 16</a:t>
             </a:r>
             <a:endParaRPr lang="en-US" sz="780" dirty="0"/>
           </a:p>

</xml_diff>